<commit_message>
Rework the Mallard document, process map and deck around the six-phase workspace
The investigator-facing process is the aims-based six-phase workspace, the
default entry since September: estimand and variables before the brief, study
build and analysis drafts as separate presses in Phase 4, execution on request,
edit previews with stale marking and pending results held for acceptance.
Six process-map panels replace five; the external design review is noted as
legacy-only; the per-stage credit model is noted as not live.

Co-Authored-By: Claude Fable 5.1 <noreply@anthropic.com>
Claude-Session: https://claude.ai/code/session_01X1f2jrPhKVq3UugerdeSjN
</commit_message>
<xml_diff>
--- a/docs/Mallard Study Design Process - leaders deck.pptx
+++ b/docs/Mallard Study Design Process - leaders deck.pptx
@@ -864,7 +864,7 @@
           <a:p>
             <a:r>
               <a:rPr lang="en-US" dirty="0"/>
-              <a:t>Two minutes. Walk the row left to right. Stress that the design decision is made first and separately, because a plan built on the wrong design is wrong throughout, and that the investigator approves it before a credit is spent. Steps 6 and 7 are on request so a power justification does not carry an unwanted abstract.</a:t>
+              <a:t>Two minutes. Walk the row left to right. Stress three things: the estimand and variables come before the design is recommended; the design is confirmed before a credit is spent; and execution, the write-up and code are drafted only when asked for. The seven generation steps of the pipeline still exist underneath, but the investigator sees these six phases.</a:t>
             </a:r>
             <a:endParaRPr lang="en-US" dirty="0"/>
           </a:p>
@@ -1392,7 +1392,7 @@
           <a:p>
             <a:r>
               <a:rPr lang="en-US" dirty="0"/>
-              <a:t>Two minutes. Do not read all eleven. Name D4, D6 and D9: the design approval that gates the credit, the optional statistician review that goes stale if anything changes, and the one revision that costs a credit. Appendix A of the document gives every option and its effect.</a:t>
+              <a:t>Two minutes. Do not read all eleven. Name D4, D8 and D9: the design approval that gates the credit, the save-or-update choice after an edit, and the explicit acceptance of anything regenerated. Appendix A of the document gives every option and its effect.</a:t>
             </a:r>
             <a:endParaRPr lang="en-US" dirty="0"/>
           </a:p>
@@ -3317,7 +3317,7 @@
                 <a:ea typeface="Cambria" pitchFamily="34" charset="-122"/>
                 <a:cs typeface="Cambria" pitchFamily="34" charset="-120"/>
               </a:rPr>
-              <a:t>7</a:t>
+              <a:t>6</a:t>
             </a:r>
             <a:endParaRPr lang="en-US" sz="6600" dirty="0"/>
           </a:p>
@@ -3356,7 +3356,7 @@
                 <a:ea typeface="Calibri" pitchFamily="34" charset="-122"/>
                 <a:cs typeface="Calibri" pitchFamily="34" charset="-120"/>
               </a:rPr>
-              <a:t>steps, built in the order a study develops, with the design settled first</a:t>
+              <a:t>workspace phases, each ending in a gate the investigator confirms, with the design settled in Phase 3</a:t>
             </a:r>
             <a:endParaRPr lang="en-US" sz="1300" dirty="0"/>
           </a:p>
@@ -3839,7 +3839,7 @@
                 <a:ea typeface="Cambria" pitchFamily="34" charset="-122"/>
                 <a:cs typeface="Cambria" pitchFamily="34" charset="-120"/>
               </a:rPr>
-              <a:t>The plan is built in the order a study develops</a:t>
+              <a:t>Six phases, each ending in a gate the investigator confirms</a:t>
             </a:r>
             <a:endParaRPr lang="en-US" sz="3400" dirty="0"/>
           </a:p>
@@ -3878,7 +3878,7 @@
                 <a:ea typeface="Calibri" pitchFamily="34" charset="-122"/>
                 <a:cs typeface="Calibri" pitchFamily="34" charset="-120"/>
               </a:rPr>
-              <a:t>A free design brief first, then six plan steps; one credit is spent at step 3</a:t>
+              <a:t>The workspace is the default entry; the design is settled in Phase 3 and the plan credit is spent in Phase 4</a:t>
             </a:r>
             <a:endParaRPr lang="en-US" sz="1500" dirty="0"/>
           </a:p>
@@ -3918,7 +3918,7 @@
         <p:spPr>
           <a:xfrm>
             <a:off x="749808" y="1490472"/>
-            <a:ext cx="2926080" cy="256032"/>
+            <a:ext cx="4206240" cy="256032"/>
           </a:xfrm>
           <a:prstGeom prst="rect">
             <a:avLst/>
@@ -3942,7 +3942,7 @@
                 <a:ea typeface="Calibri" pitchFamily="34" charset="-122"/>
                 <a:cs typeface="Calibri" pitchFamily="34" charset="-120"/>
               </a:rPr>
-              <a:t>Reviewed by two model labs</a:t>
+              <a:t>Models draft; two labs review the brief and the analyses</a:t>
             </a:r>
             <a:endParaRPr lang="en-US" sz="1150" dirty="0"/>
           </a:p>
@@ -3956,7 +3956,7 @@
         </p:nvSpPr>
         <p:spPr>
           <a:xfrm>
-            <a:off x="3291840" y="1554480"/>
+            <a:off x="4937760" y="1554480"/>
             <a:ext cx="118872" cy="118872"/>
           </a:xfrm>
           <a:prstGeom prst="rect">
@@ -3981,8 +3981,8 @@
         </p:nvSpPr>
         <p:spPr>
           <a:xfrm>
-            <a:off x="3474720" y="1490472"/>
-            <a:ext cx="3108960" cy="256032"/>
+            <a:off x="5120640" y="1490472"/>
+            <a:ext cx="2926080" cy="256032"/>
           </a:xfrm>
           <a:prstGeom prst="rect">
             <a:avLst/>
@@ -4006,7 +4006,7 @@
                 <a:ea typeface="Calibri" pitchFamily="34" charset="-122"/>
                 <a:cs typeface="Calibri" pitchFamily="34" charset="-120"/>
               </a:rPr>
-              <a:t>Deterministic checks only</a:t>
+              <a:t>Deterministic gates and checks</a:t>
             </a:r>
             <a:endParaRPr lang="en-US" sz="1150" dirty="0"/>
           </a:p>
@@ -4020,7 +4020,7 @@
         </p:nvSpPr>
         <p:spPr>
           <a:xfrm>
-            <a:off x="6126480" y="1554480"/>
+            <a:off x="8138160" y="1554480"/>
             <a:ext cx="118872" cy="118872"/>
           </a:xfrm>
           <a:prstGeom prst="rect">
@@ -4045,8 +4045,8 @@
         </p:nvSpPr>
         <p:spPr>
           <a:xfrm>
-            <a:off x="6309360" y="1490472"/>
-            <a:ext cx="3657600" cy="256032"/>
+            <a:off x="8321040" y="1490472"/>
+            <a:ext cx="3291840" cy="256032"/>
           </a:xfrm>
           <a:prstGeom prst="rect">
             <a:avLst/>
@@ -4070,7 +4070,7 @@
                 <a:ea typeface="Calibri" pitchFamily="34" charset="-122"/>
                 <a:cs typeface="Calibri" pitchFamily="34" charset="-120"/>
               </a:rPr>
-              <a:t>Investigator answers questions here</a:t>
+              <a:t>Generated on the investigator's press</a:t>
             </a:r>
             <a:endParaRPr lang="en-US" sz="1150" dirty="0"/>
           </a:p>
@@ -4085,7 +4085,7 @@
         <p:spPr>
           <a:xfrm>
             <a:off x="566928" y="2011680"/>
-            <a:ext cx="1481328" cy="1051560"/>
+            <a:ext cx="1737360" cy="1051560"/>
           </a:xfrm>
           <a:prstGeom prst="roundRect">
             <a:avLst>
@@ -4112,7 +4112,7 @@
         <p:spPr>
           <a:xfrm>
             <a:off x="566928" y="2953512"/>
-            <a:ext cx="1481328" cy="109728"/>
+            <a:ext cx="1737360" cy="109728"/>
           </a:xfrm>
           <a:prstGeom prst="rect">
             <a:avLst/>
@@ -4137,11 +4137,11 @@
         <p:spPr>
           <a:xfrm>
             <a:off x="566928" y="3063240"/>
-            <a:ext cx="1481328" cy="2148840"/>
+            <a:ext cx="1737360" cy="2148840"/>
           </a:xfrm>
           <a:prstGeom prst="roundRect">
             <a:avLst>
-              <a:gd name="adj" fmla="val 4938"/>
+              <a:gd name="adj" fmla="val 4211"/>
             </a:avLst>
           </a:prstGeom>
           <a:solidFill>
@@ -4164,7 +4164,7 @@
         <p:spPr>
           <a:xfrm>
             <a:off x="566928" y="3063240"/>
-            <a:ext cx="1481328" cy="91440"/>
+            <a:ext cx="1737360" cy="91440"/>
           </a:xfrm>
           <a:prstGeom prst="rect">
             <a:avLst/>
@@ -4189,7 +4189,7 @@
         <p:spPr>
           <a:xfrm>
             <a:off x="731520" y="2112264"/>
-            <a:ext cx="1152144" cy="201168"/>
+            <a:ext cx="1408176" cy="201168"/>
           </a:xfrm>
           <a:prstGeom prst="rect">
             <a:avLst/>
@@ -4213,7 +4213,7 @@
                 <a:ea typeface="Consolas" pitchFamily="34" charset="-122"/>
                 <a:cs typeface="Consolas" pitchFamily="34" charset="-120"/>
               </a:rPr>
-              <a:t>STEP 1</a:t>
+              <a:t>PHASE 1</a:t>
             </a:r>
             <a:endParaRPr lang="en-US" sz="950" dirty="0"/>
           </a:p>
@@ -4228,7 +4228,7 @@
         <p:spPr>
           <a:xfrm>
             <a:off x="731520" y="2304288"/>
-            <a:ext cx="1152144" cy="667512"/>
+            <a:ext cx="1408176" cy="667512"/>
           </a:xfrm>
           <a:prstGeom prst="rect">
             <a:avLst/>
@@ -4252,7 +4252,7 @@
                 <a:ea typeface="Cambria" pitchFamily="34" charset="-122"/>
                 <a:cs typeface="Cambria" pitchFamily="34" charset="-120"/>
               </a:rPr>
-              <a:t>Question and data</a:t>
+              <a:t>Question and aims</a:t>
             </a:r>
             <a:endParaRPr lang="en-US" sz="1400" dirty="0"/>
           </a:p>
@@ -4267,7 +4267,7 @@
         <p:spPr>
           <a:xfrm>
             <a:off x="713232" y="3191256"/>
-            <a:ext cx="1188720" cy="1892808"/>
+            <a:ext cx="1444752" cy="1892808"/>
           </a:xfrm>
           <a:prstGeom prst="rect">
             <a:avLst/>
@@ -4298,7 +4298,7 @@
         <p:spPr>
           <a:xfrm>
             <a:off x="694944" y="3200400"/>
-            <a:ext cx="1225296" cy="1463040"/>
+            <a:ext cx="1481328" cy="1600200"/>
           </a:xfrm>
           <a:prstGeom prst="rect">
             <a:avLst/>
@@ -4325,7 +4325,7 @@
                 <a:ea typeface="Calibri" pitchFamily="34" charset="-122"/>
                 <a:cs typeface="Calibri" pitchFamily="34" charset="-120"/>
               </a:rPr>
-              <a:t>What am I asking, has it been answered, what records do I have?</a:t>
+              <a:t>Aims suggested with placeholders; roles and claims set; the aims check; a PubMed literature scan.</a:t>
             </a:r>
             <a:endParaRPr lang="en-US" sz="950" dirty="0"/>
           </a:p>
@@ -4342,7 +4342,7 @@
                 <a:ea typeface="Calibri" pitchFamily="34" charset="-122"/>
                 <a:cs typeface="Calibri" pitchFamily="34" charset="-120"/>
               </a:rPr>
-              <a:t>Free. Nothing generated.</a:t>
+              <a:t>Free. Gate: 1 to 3 aims with roles.</a:t>
             </a:r>
             <a:endParaRPr lang="en-US" sz="950" dirty="0"/>
           </a:p>
@@ -4361,6 +4361,33 @@
           </a:xfrm>
           <a:prstGeom prst="rect">
             <a:avLst/>
+          </a:prstGeom>
+          <a:solidFill>
+            <a:srgbClr val="9A6B0F"/>
+          </a:solidFill>
+          <a:ln w="12700">
+            <a:solidFill>
+              <a:srgbClr val="9A6B0F"/>
+            </a:solidFill>
+            <a:prstDash val="solid"/>
+          </a:ln>
+        </p:spPr>
+      </p:sp>
+      <p:sp>
+        <p:nvSpPr>
+          <p:cNvPr id="19" name="Shape 17"/>
+          <p:cNvSpPr/>
+          <p:nvPr/>
+        </p:nvSpPr>
+        <p:spPr>
+          <a:xfrm>
+            <a:off x="2437790" y="2011680"/>
+            <a:ext cx="1737360" cy="1051560"/>
+          </a:xfrm>
+          <a:prstGeom prst="roundRect">
+            <a:avLst>
+              <a:gd name="adj" fmla="val 6957"/>
+            </a:avLst>
           </a:prstGeom>
           <a:solidFill>
             <a:srgbClr val="0F4C43"/>
@@ -4375,19 +4402,17 @@
       </p:sp>
       <p:sp>
         <p:nvSpPr>
-          <p:cNvPr id="19" name="Shape 17"/>
+          <p:cNvPr id="20" name="Shape 18"/>
           <p:cNvSpPr/>
           <p:nvPr/>
         </p:nvSpPr>
         <p:spPr>
           <a:xfrm>
-            <a:off x="2167128" y="2011680"/>
-            <a:ext cx="1481328" cy="1051560"/>
-          </a:xfrm>
-          <a:prstGeom prst="roundRect">
-            <a:avLst>
-              <a:gd name="adj" fmla="val 6957"/>
-            </a:avLst>
+            <a:off x="2437790" y="2953512"/>
+            <a:ext cx="1737360" cy="109728"/>
+          </a:xfrm>
+          <a:prstGeom prst="rect">
+            <a:avLst/>
           </a:prstGeom>
           <a:solidFill>
             <a:srgbClr val="0F4C43"/>
@@ -4402,14 +4427,234 @@
       </p:sp>
       <p:sp>
         <p:nvSpPr>
-          <p:cNvPr id="20" name="Shape 18"/>
+          <p:cNvPr id="21" name="Shape 19"/>
           <p:cNvSpPr/>
           <p:nvPr/>
         </p:nvSpPr>
         <p:spPr>
           <a:xfrm>
-            <a:off x="2167128" y="2953512"/>
-            <a:ext cx="1481328" cy="109728"/>
+            <a:off x="2437790" y="3063240"/>
+            <a:ext cx="1737360" cy="2148840"/>
+          </a:xfrm>
+          <a:prstGeom prst="roundRect">
+            <a:avLst>
+              <a:gd name="adj" fmla="val 4211"/>
+            </a:avLst>
+          </a:prstGeom>
+          <a:solidFill>
+            <a:srgbClr val="F7FAF9"/>
+          </a:solidFill>
+          <a:ln w="12700">
+            <a:solidFill>
+              <a:srgbClr val="F7FAF9"/>
+            </a:solidFill>
+            <a:prstDash val="solid"/>
+          </a:ln>
+        </p:spPr>
+      </p:sp>
+      <p:sp>
+        <p:nvSpPr>
+          <p:cNvPr id="22" name="Shape 20"/>
+          <p:cNvSpPr/>
+          <p:nvPr/>
+        </p:nvSpPr>
+        <p:spPr>
+          <a:xfrm>
+            <a:off x="2437790" y="3063240"/>
+            <a:ext cx="1737360" cy="91440"/>
+          </a:xfrm>
+          <a:prstGeom prst="rect">
+            <a:avLst/>
+          </a:prstGeom>
+          <a:solidFill>
+            <a:srgbClr val="F7FAF9"/>
+          </a:solidFill>
+          <a:ln w="12700">
+            <a:solidFill>
+              <a:srgbClr val="F7FAF9"/>
+            </a:solidFill>
+            <a:prstDash val="solid"/>
+          </a:ln>
+        </p:spPr>
+      </p:sp>
+      <p:sp>
+        <p:nvSpPr>
+          <p:cNvPr id="23" name="Text 21"/>
+          <p:cNvSpPr txBox="1"/>
+          <p:nvPr/>
+        </p:nvSpPr>
+        <p:spPr>
+          <a:xfrm>
+            <a:off x="2602382" y="2112264"/>
+            <a:ext cx="1408176" cy="201168"/>
+          </a:xfrm>
+          <a:prstGeom prst="rect">
+            <a:avLst/>
+          </a:prstGeom>
+          <a:noFill/>
+          <a:ln/>
+        </p:spPr>
+        <p:txBody>
+          <a:bodyPr wrap="square" lIns="0" tIns="0" rIns="0" bIns="0" rtlCol="0" anchor="ctr"/>
+          <a:lstStyle/>
+          <a:p>
+            <a:pPr indent="0" marL="0">
+              <a:buNone/>
+            </a:pPr>
+            <a:r>
+              <a:rPr lang="en-US" sz="950" b="1" dirty="0">
+                <a:solidFill>
+                  <a:srgbClr val="8FC3B5"/>
+                </a:solidFill>
+                <a:latin typeface="Consolas" pitchFamily="34" charset="0"/>
+                <a:ea typeface="Consolas" pitchFamily="34" charset="-122"/>
+                <a:cs typeface="Consolas" pitchFamily="34" charset="-120"/>
+              </a:rPr>
+              <a:t>PHASE 2</a:t>
+            </a:r>
+            <a:endParaRPr lang="en-US" sz="950" dirty="0"/>
+          </a:p>
+        </p:txBody>
+      </p:sp>
+      <p:sp>
+        <p:nvSpPr>
+          <p:cNvPr id="24" name="Text 22"/>
+          <p:cNvSpPr txBox="1"/>
+          <p:nvPr/>
+        </p:nvSpPr>
+        <p:spPr>
+          <a:xfrm>
+            <a:off x="2602382" y="2304288"/>
+            <a:ext cx="1408176" cy="667512"/>
+          </a:xfrm>
+          <a:prstGeom prst="rect">
+            <a:avLst/>
+          </a:prstGeom>
+          <a:noFill/>
+          <a:ln/>
+        </p:spPr>
+        <p:txBody>
+          <a:bodyPr wrap="square" lIns="0" tIns="0" rIns="0" bIns="0" rtlCol="0" anchor="t"/>
+          <a:lstStyle/>
+          <a:p>
+            <a:pPr indent="0" marL="0">
+              <a:buNone/>
+            </a:pPr>
+            <a:r>
+              <a:rPr lang="en-US" sz="1400" b="1" dirty="0">
+                <a:solidFill>
+                  <a:srgbClr val="FFFFFF"/>
+                </a:solidFill>
+                <a:latin typeface="Cambria" pitchFamily="34" charset="0"/>
+                <a:ea typeface="Cambria" pitchFamily="34" charset="-122"/>
+                <a:cs typeface="Cambria" pitchFamily="34" charset="-120"/>
+              </a:rPr>
+              <a:t>Feasibility</a:t>
+            </a:r>
+            <a:endParaRPr lang="en-US" sz="1400" dirty="0"/>
+          </a:p>
+        </p:txBody>
+      </p:sp>
+      <p:sp>
+        <p:nvSpPr>
+          <p:cNvPr id="25" name="Text 23"/>
+          <p:cNvSpPr txBox="1"/>
+          <p:nvPr/>
+        </p:nvSpPr>
+        <p:spPr>
+          <a:xfrm>
+            <a:off x="2584094" y="3191256"/>
+            <a:ext cx="1444752" cy="1892808"/>
+          </a:xfrm>
+          <a:prstGeom prst="rect">
+            <a:avLst/>
+          </a:prstGeom>
+          <a:noFill/>
+          <a:ln/>
+        </p:spPr>
+        <p:txBody>
+          <a:bodyPr wrap="square" lIns="0" tIns="0" rIns="0" bIns="0" rtlCol="0" anchor="t"/>
+          <a:lstStyle/>
+          <a:p>
+            <a:pPr indent="0" marL="0">
+              <a:spcAft>
+                <a:spcPts val="400"/>
+              </a:spcAft>
+              <a:buNone/>
+            </a:pPr>
+            <a:endParaRPr lang="en-US" sz="900" dirty="0"/>
+          </a:p>
+        </p:txBody>
+      </p:sp>
+      <p:sp>
+        <p:nvSpPr>
+          <p:cNvPr id="26" name="Text 24"/>
+          <p:cNvSpPr txBox="1"/>
+          <p:nvPr/>
+        </p:nvSpPr>
+        <p:spPr>
+          <a:xfrm>
+            <a:off x="2565806" y="3200400"/>
+            <a:ext cx="1481328" cy="1600200"/>
+          </a:xfrm>
+          <a:prstGeom prst="rect">
+            <a:avLst/>
+          </a:prstGeom>
+          <a:noFill/>
+          <a:ln/>
+        </p:spPr>
+        <p:txBody>
+          <a:bodyPr wrap="square" lIns="0" tIns="0" rIns="0" bIns="0" rtlCol="0" anchor="t"/>
+          <a:lstStyle/>
+          <a:p>
+            <a:pPr indent="0" marL="0">
+              <a:spcAft>
+                <a:spcPts val="600"/>
+              </a:spcAft>
+              <a:buNone/>
+            </a:pPr>
+            <a:r>
+              <a:rPr lang="en-US" sz="950" dirty="0">
+                <a:solidFill>
+                  <a:srgbClr val="16202B"/>
+                </a:solidFill>
+                <a:latin typeface="Calibri" pitchFamily="34" charset="0"/>
+                <a:ea typeface="Calibri" pitchFamily="34" charset="-122"/>
+                <a:cs typeface="Calibri" pitchFamily="34" charset="-120"/>
+              </a:rPr>
+              <a:t>Seven questions, each answered with a basis and an owner; the variable map on request.</a:t>
+            </a:r>
+            <a:endParaRPr lang="en-US" sz="950" dirty="0"/>
+          </a:p>
+          <a:p>
+            <a:pPr indent="0" marL="0">
+              <a:buNone/>
+            </a:pPr>
+            <a:r>
+              <a:rPr lang="en-US" sz="950" b="1" dirty="0">
+                <a:solidFill>
+                  <a:srgbClr val="0F4C43"/>
+                </a:solidFill>
+                <a:latin typeface="Calibri" pitchFamily="34" charset="0"/>
+                <a:ea typeface="Calibri" pitchFamily="34" charset="-122"/>
+                <a:cs typeface="Calibri" pitchFamily="34" charset="-120"/>
+              </a:rPr>
+              <a:t>Free. Gate: every row has a basis and a result.</a:t>
+            </a:r>
+            <a:endParaRPr lang="en-US" sz="950" dirty="0"/>
+          </a:p>
+        </p:txBody>
+      </p:sp>
+      <p:sp>
+        <p:nvSpPr>
+          <p:cNvPr id="27" name="Shape 25"/>
+          <p:cNvSpPr/>
+          <p:nvPr/>
+        </p:nvSpPr>
+        <p:spPr>
+          <a:xfrm>
+            <a:off x="2565806" y="4937760"/>
+            <a:ext cx="118872" cy="118872"/>
           </a:xfrm>
           <a:prstGeom prst="rect">
             <a:avLst/>
@@ -4427,18 +4672,70 @@
       </p:sp>
       <p:sp>
         <p:nvSpPr>
-          <p:cNvPr id="21" name="Shape 19"/>
+          <p:cNvPr id="28" name="Shape 26"/>
           <p:cNvSpPr/>
           <p:nvPr/>
         </p:nvSpPr>
         <p:spPr>
           <a:xfrm>
-            <a:off x="2167128" y="3063240"/>
-            <a:ext cx="1481328" cy="2148840"/>
+            <a:off x="4308653" y="2011680"/>
+            <a:ext cx="1737360" cy="1051560"/>
           </a:xfrm>
           <a:prstGeom prst="roundRect">
             <a:avLst>
-              <a:gd name="adj" fmla="val 4938"/>
+              <a:gd name="adj" fmla="val 6957"/>
+            </a:avLst>
+          </a:prstGeom>
+          <a:solidFill>
+            <a:srgbClr val="0F4C43"/>
+          </a:solidFill>
+          <a:ln w="12700">
+            <a:solidFill>
+              <a:srgbClr val="0F4C43"/>
+            </a:solidFill>
+            <a:prstDash val="solid"/>
+          </a:ln>
+        </p:spPr>
+      </p:sp>
+      <p:sp>
+        <p:nvSpPr>
+          <p:cNvPr id="29" name="Shape 27"/>
+          <p:cNvSpPr/>
+          <p:nvPr/>
+        </p:nvSpPr>
+        <p:spPr>
+          <a:xfrm>
+            <a:off x="4308653" y="2953512"/>
+            <a:ext cx="1737360" cy="109728"/>
+          </a:xfrm>
+          <a:prstGeom prst="rect">
+            <a:avLst/>
+          </a:prstGeom>
+          <a:solidFill>
+            <a:srgbClr val="0F4C43"/>
+          </a:solidFill>
+          <a:ln w="12700">
+            <a:solidFill>
+              <a:srgbClr val="0F4C43"/>
+            </a:solidFill>
+            <a:prstDash val="solid"/>
+          </a:ln>
+        </p:spPr>
+      </p:sp>
+      <p:sp>
+        <p:nvSpPr>
+          <p:cNvPr id="30" name="Shape 28"/>
+          <p:cNvSpPr/>
+          <p:nvPr/>
+        </p:nvSpPr>
+        <p:spPr>
+          <a:xfrm>
+            <a:off x="4308653" y="3063240"/>
+            <a:ext cx="1737360" cy="2148840"/>
+          </a:xfrm>
+          <a:prstGeom prst="roundRect">
+            <a:avLst>
+              <a:gd name="adj" fmla="val 4211"/>
             </a:avLst>
           </a:prstGeom>
           <a:solidFill>
@@ -4454,14 +4751,14 @@
       </p:sp>
       <p:sp>
         <p:nvSpPr>
-          <p:cNvPr id="22" name="Shape 20"/>
+          <p:cNvPr id="31" name="Shape 29"/>
           <p:cNvSpPr/>
           <p:nvPr/>
         </p:nvSpPr>
         <p:spPr>
           <a:xfrm>
-            <a:off x="2167128" y="3063240"/>
-            <a:ext cx="1481328" cy="91440"/>
+            <a:off x="4308653" y="3063240"/>
+            <a:ext cx="1737360" cy="91440"/>
           </a:xfrm>
           <a:prstGeom prst="rect">
             <a:avLst/>
@@ -4479,14 +4776,14 @@
       </p:sp>
       <p:sp>
         <p:nvSpPr>
-          <p:cNvPr id="23" name="Text 21"/>
-          <p:cNvSpPr txBox="1"/>
-          <p:nvPr/>
-        </p:nvSpPr>
-        <p:spPr>
-          <a:xfrm>
-            <a:off x="2331720" y="2112264"/>
-            <a:ext cx="1152144" cy="201168"/>
+          <p:cNvPr id="32" name="Text 30"/>
+          <p:cNvSpPr txBox="1"/>
+          <p:nvPr/>
+        </p:nvSpPr>
+        <p:spPr>
+          <a:xfrm>
+            <a:off x="4473245" y="2112264"/>
+            <a:ext cx="1408176" cy="201168"/>
           </a:xfrm>
           <a:prstGeom prst="rect">
             <a:avLst/>
@@ -4510,7 +4807,7 @@
                 <a:ea typeface="Consolas" pitchFamily="34" charset="-122"/>
                 <a:cs typeface="Consolas" pitchFamily="34" charset="-120"/>
               </a:rPr>
-              <a:t>STEP 2</a:t>
+              <a:t>PHASE 3</a:t>
             </a:r>
             <a:endParaRPr lang="en-US" sz="950" dirty="0"/>
           </a:p>
@@ -4518,14 +4815,14 @@
       </p:sp>
       <p:sp>
         <p:nvSpPr>
-          <p:cNvPr id="24" name="Text 22"/>
-          <p:cNvSpPr txBox="1"/>
-          <p:nvPr/>
-        </p:nvSpPr>
-        <p:spPr>
-          <a:xfrm>
-            <a:off x="2331720" y="2304288"/>
-            <a:ext cx="1152144" cy="667512"/>
+          <p:cNvPr id="33" name="Text 31"/>
+          <p:cNvSpPr txBox="1"/>
+          <p:nvPr/>
+        </p:nvSpPr>
+        <p:spPr>
+          <a:xfrm>
+            <a:off x="4473245" y="2304288"/>
+            <a:ext cx="1408176" cy="667512"/>
           </a:xfrm>
           <a:prstGeom prst="rect">
             <a:avLst/>
@@ -4549,7 +4846,7 @@
                 <a:ea typeface="Cambria" pitchFamily="34" charset="-122"/>
                 <a:cs typeface="Cambria" pitchFamily="34" charset="-120"/>
               </a:rPr>
-              <a:t>Design brief</a:t>
+              <a:t>Design confirmation</a:t>
             </a:r>
             <a:endParaRPr lang="en-US" sz="1400" dirty="0"/>
           </a:p>
@@ -4557,14 +4854,14 @@
       </p:sp>
       <p:sp>
         <p:nvSpPr>
-          <p:cNvPr id="25" name="Text 23"/>
-          <p:cNvSpPr txBox="1"/>
-          <p:nvPr/>
-        </p:nvSpPr>
-        <p:spPr>
-          <a:xfrm>
-            <a:off x="2313432" y="3191256"/>
-            <a:ext cx="1188720" cy="1892808"/>
+          <p:cNvPr id="34" name="Text 32"/>
+          <p:cNvSpPr txBox="1"/>
+          <p:nvPr/>
+        </p:nvSpPr>
+        <p:spPr>
+          <a:xfrm>
+            <a:off x="4454957" y="3191256"/>
+            <a:ext cx="1444752" cy="1892808"/>
           </a:xfrm>
           <a:prstGeom prst="rect">
             <a:avLst/>
@@ -4588,14 +4885,14 @@
       </p:sp>
       <p:sp>
         <p:nvSpPr>
-          <p:cNvPr id="26" name="Text 24"/>
-          <p:cNvSpPr txBox="1"/>
-          <p:nvPr/>
-        </p:nvSpPr>
-        <p:spPr>
-          <a:xfrm>
-            <a:off x="2295144" y="3200400"/>
-            <a:ext cx="1225296" cy="1463040"/>
+          <p:cNvPr id="35" name="Text 33"/>
+          <p:cNvSpPr txBox="1"/>
+          <p:nvPr/>
+        </p:nvSpPr>
+        <p:spPr>
+          <a:xfrm>
+            <a:off x="4436669" y="3200400"/>
+            <a:ext cx="1481328" cy="1600200"/>
           </a:xfrm>
           <a:prstGeom prst="rect">
             <a:avLst/>
@@ -4622,7 +4919,7 @@
                 <a:ea typeface="Calibri" pitchFamily="34" charset="-122"/>
                 <a:cs typeface="Calibri" pitchFamily="34" charset="-120"/>
               </a:rPr>
-              <a:t>The design and why, the typed estimand, the conditions it depends on, the alternatives.</a:t>
+              <a:t>Estimand and variables first, then the free brief: design, conditions, up to three alternatives.</a:t>
             </a:r>
             <a:endParaRPr lang="en-US" sz="950" dirty="0"/>
           </a:p>
@@ -4639,7 +4936,7 @@
                 <a:ea typeface="Calibri" pitchFamily="34" charset="-122"/>
                 <a:cs typeface="Calibri" pitchFamily="34" charset="-120"/>
               </a:rPr>
-              <a:t>Free. Two-lab review.</a:t>
+              <a:t>Free brief. Gate: estimand, variables, design confirmed.</a:t>
             </a:r>
             <a:endParaRPr lang="en-US" sz="950" dirty="0"/>
           </a:p>
@@ -4647,13 +4944,13 @@
       </p:sp>
       <p:sp>
         <p:nvSpPr>
-          <p:cNvPr id="27" name="Shape 25"/>
+          <p:cNvPr id="36" name="Shape 34"/>
           <p:cNvSpPr/>
           <p:nvPr/>
         </p:nvSpPr>
         <p:spPr>
           <a:xfrm>
-            <a:off x="2295144" y="4937760"/>
+            <a:off x="4436669" y="4937760"/>
             <a:ext cx="118872" cy="118872"/>
           </a:xfrm>
           <a:prstGeom prst="rect">
@@ -4672,53 +4969,14 @@
       </p:sp>
       <p:sp>
         <p:nvSpPr>
-          <p:cNvPr id="28" name="Text 26"/>
-          <p:cNvSpPr txBox="1"/>
-          <p:nvPr/>
-        </p:nvSpPr>
-        <p:spPr>
-          <a:xfrm>
-            <a:off x="2478024" y="4873752"/>
-            <a:ext cx="1115568" cy="256032"/>
-          </a:xfrm>
-          <a:prstGeom prst="rect">
-            <a:avLst/>
-          </a:prstGeom>
-          <a:noFill/>
-          <a:ln/>
-        </p:spPr>
-        <p:txBody>
-          <a:bodyPr wrap="square" lIns="0" tIns="0" rIns="0" bIns="0" rtlCol="0" anchor="ctr"/>
-          <a:lstStyle/>
-          <a:p>
-            <a:pPr indent="0" marL="0">
-              <a:buNone/>
-            </a:pPr>
-            <a:r>
-              <a:rPr lang="en-US" sz="800" b="1" dirty="0">
-                <a:solidFill>
-                  <a:srgbClr val="9A6B0F"/>
-                </a:solidFill>
-                <a:latin typeface="Consolas" pitchFamily="34" charset="0"/>
-                <a:ea typeface="Consolas" pitchFamily="34" charset="-122"/>
-                <a:cs typeface="Consolas" pitchFamily="34" charset="-120"/>
-              </a:rPr>
-              <a:t>2 questions asked</a:t>
-            </a:r>
-            <a:endParaRPr lang="en-US" sz="800" dirty="0"/>
-          </a:p>
-        </p:txBody>
-      </p:sp>
-      <p:sp>
-        <p:nvSpPr>
-          <p:cNvPr id="29" name="Shape 27"/>
+          <p:cNvPr id="37" name="Shape 35"/>
           <p:cNvSpPr/>
           <p:nvPr/>
         </p:nvSpPr>
         <p:spPr>
           <a:xfrm>
-            <a:off x="3767328" y="2011680"/>
-            <a:ext cx="1481328" cy="1051560"/>
+            <a:off x="6179515" y="2011680"/>
+            <a:ext cx="1737360" cy="1051560"/>
           </a:xfrm>
           <a:prstGeom prst="roundRect">
             <a:avLst>
@@ -4738,14 +4996,14 @@
       </p:sp>
       <p:sp>
         <p:nvSpPr>
-          <p:cNvPr id="30" name="Shape 28"/>
+          <p:cNvPr id="38" name="Shape 36"/>
           <p:cNvSpPr/>
           <p:nvPr/>
         </p:nvSpPr>
         <p:spPr>
           <a:xfrm>
-            <a:off x="3767328" y="2953512"/>
-            <a:ext cx="1481328" cy="109728"/>
+            <a:off x="6179515" y="2953512"/>
+            <a:ext cx="1737360" cy="109728"/>
           </a:xfrm>
           <a:prstGeom prst="rect">
             <a:avLst/>
@@ -4763,18 +5021,18 @@
       </p:sp>
       <p:sp>
         <p:nvSpPr>
-          <p:cNvPr id="31" name="Shape 29"/>
+          <p:cNvPr id="39" name="Shape 37"/>
           <p:cNvSpPr/>
           <p:nvPr/>
         </p:nvSpPr>
         <p:spPr>
           <a:xfrm>
-            <a:off x="3767328" y="3063240"/>
-            <a:ext cx="1481328" cy="2148840"/>
+            <a:off x="6179515" y="3063240"/>
+            <a:ext cx="1737360" cy="2148840"/>
           </a:xfrm>
           <a:prstGeom prst="roundRect">
             <a:avLst>
-              <a:gd name="adj" fmla="val 4938"/>
+              <a:gd name="adj" fmla="val 4211"/>
             </a:avLst>
           </a:prstGeom>
           <a:solidFill>
@@ -4790,14 +5048,14 @@
       </p:sp>
       <p:sp>
         <p:nvSpPr>
-          <p:cNvPr id="32" name="Shape 30"/>
+          <p:cNvPr id="40" name="Shape 38"/>
           <p:cNvSpPr/>
           <p:nvPr/>
         </p:nvSpPr>
         <p:spPr>
           <a:xfrm>
-            <a:off x="3767328" y="3063240"/>
-            <a:ext cx="1481328" cy="91440"/>
+            <a:off x="6179515" y="3063240"/>
+            <a:ext cx="1737360" cy="91440"/>
           </a:xfrm>
           <a:prstGeom prst="rect">
             <a:avLst/>
@@ -4815,14 +5073,14 @@
       </p:sp>
       <p:sp>
         <p:nvSpPr>
-          <p:cNvPr id="33" name="Text 31"/>
-          <p:cNvSpPr txBox="1"/>
-          <p:nvPr/>
-        </p:nvSpPr>
-        <p:spPr>
-          <a:xfrm>
-            <a:off x="3931920" y="2112264"/>
-            <a:ext cx="1152144" cy="201168"/>
+          <p:cNvPr id="41" name="Text 39"/>
+          <p:cNvSpPr txBox="1"/>
+          <p:nvPr/>
+        </p:nvSpPr>
+        <p:spPr>
+          <a:xfrm>
+            <a:off x="6344107" y="2112264"/>
+            <a:ext cx="1408176" cy="201168"/>
           </a:xfrm>
           <a:prstGeom prst="rect">
             <a:avLst/>
@@ -4846,7 +5104,7 @@
                 <a:ea typeface="Consolas" pitchFamily="34" charset="-122"/>
                 <a:cs typeface="Consolas" pitchFamily="34" charset="-120"/>
               </a:rPr>
-              <a:t>STEP 3</a:t>
+              <a:t>PHASE 4</a:t>
             </a:r>
             <a:endParaRPr lang="en-US" sz="950" dirty="0"/>
           </a:p>
@@ -4854,14 +5112,14 @@
       </p:sp>
       <p:sp>
         <p:nvSpPr>
-          <p:cNvPr id="34" name="Text 32"/>
-          <p:cNvSpPr txBox="1"/>
-          <p:nvPr/>
-        </p:nvSpPr>
-        <p:spPr>
-          <a:xfrm>
-            <a:off x="3931920" y="2304288"/>
-            <a:ext cx="1152144" cy="667512"/>
+          <p:cNvPr id="42" name="Text 40"/>
+          <p:cNvSpPr txBox="1"/>
+          <p:nvPr/>
+        </p:nvSpPr>
+        <p:spPr>
+          <a:xfrm>
+            <a:off x="6344107" y="2304288"/>
+            <a:ext cx="1408176" cy="667512"/>
           </a:xfrm>
           <a:prstGeom prst="rect">
             <a:avLst/>
@@ -4885,7 +5143,7 @@
                 <a:ea typeface="Cambria" pitchFamily="34" charset="-122"/>
                 <a:cs typeface="Cambria" pitchFamily="34" charset="-120"/>
               </a:rPr>
-              <a:t>Patients and data</a:t>
+              <a:t>Analysis and sizing</a:t>
             </a:r>
             <a:endParaRPr lang="en-US" sz="1400" dirty="0"/>
           </a:p>
@@ -4893,14 +5151,14 @@
       </p:sp>
       <p:sp>
         <p:nvSpPr>
-          <p:cNvPr id="35" name="Text 33"/>
-          <p:cNvSpPr txBox="1"/>
-          <p:nvPr/>
-        </p:nvSpPr>
-        <p:spPr>
-          <a:xfrm>
-            <a:off x="3913632" y="3191256"/>
-            <a:ext cx="1188720" cy="1892808"/>
+          <p:cNvPr id="43" name="Text 41"/>
+          <p:cNvSpPr txBox="1"/>
+          <p:nvPr/>
+        </p:nvSpPr>
+        <p:spPr>
+          <a:xfrm>
+            <a:off x="6325819" y="3191256"/>
+            <a:ext cx="1444752" cy="1892808"/>
           </a:xfrm>
           <a:prstGeom prst="rect">
             <a:avLst/>
@@ -4924,14 +5182,14 @@
       </p:sp>
       <p:sp>
         <p:nvSpPr>
-          <p:cNvPr id="36" name="Text 34"/>
-          <p:cNvSpPr txBox="1"/>
-          <p:nvPr/>
-        </p:nvSpPr>
-        <p:spPr>
-          <a:xfrm>
-            <a:off x="3895344" y="3200400"/>
-            <a:ext cx="1225296" cy="1463040"/>
+          <p:cNvPr id="44" name="Text 42"/>
+          <p:cNvSpPr txBox="1"/>
+          <p:nvPr/>
+        </p:nvSpPr>
+        <p:spPr>
+          <a:xfrm>
+            <a:off x="6307531" y="3200400"/>
+            <a:ext cx="1481328" cy="1600200"/>
           </a:xfrm>
           <a:prstGeom prst="rect">
             <a:avLst/>
@@ -4958,7 +5216,7 @@
                 <a:ea typeface="Calibri" pitchFamily="34" charset="-122"/>
                 <a:cs typeface="Calibri" pitchFamily="34" charset="-120"/>
               </a:rPr>
-              <a:t>Who is in, what is measured, where the records come from, who must say yes.</a:t>
+              <a:t>Build the study, then draft each aim's analysis, sizing and exhibits; edit, update, accept.</a:t>
             </a:r>
             <a:endParaRPr lang="en-US" sz="950" dirty="0"/>
           </a:p>
@@ -4975,7 +5233,7 @@
                 <a:ea typeface="Calibri" pitchFamily="34" charset="-122"/>
                 <a:cs typeface="Calibri" pitchFamily="34" charset="-120"/>
               </a:rPr>
-              <a:t>Spends the credit. Sign-in required.</a:t>
+              <a:t>One plan credit. Gate: the biostatistician checkpoint.</a:t>
             </a:r>
             <a:endParaRPr lang="en-US" sz="950" dirty="0"/>
           </a:p>
@@ -4983,17 +5241,44 @@
       </p:sp>
       <p:sp>
         <p:nvSpPr>
-          <p:cNvPr id="37" name="Shape 35"/>
+          <p:cNvPr id="45" name="Shape 43"/>
           <p:cNvSpPr/>
           <p:nvPr/>
         </p:nvSpPr>
         <p:spPr>
           <a:xfrm>
-            <a:off x="3895344" y="4937760"/>
+            <a:off x="6307531" y="4937760"/>
             <a:ext cx="118872" cy="118872"/>
           </a:xfrm>
           <a:prstGeom prst="rect">
             <a:avLst/>
+          </a:prstGeom>
+          <a:solidFill>
+            <a:srgbClr val="D9AC5A"/>
+          </a:solidFill>
+          <a:ln w="12700">
+            <a:solidFill>
+              <a:srgbClr val="D9AC5A"/>
+            </a:solidFill>
+            <a:prstDash val="solid"/>
+          </a:ln>
+        </p:spPr>
+      </p:sp>
+      <p:sp>
+        <p:nvSpPr>
+          <p:cNvPr id="46" name="Shape 44"/>
+          <p:cNvSpPr/>
+          <p:nvPr/>
+        </p:nvSpPr>
+        <p:spPr>
+          <a:xfrm>
+            <a:off x="8050378" y="2011680"/>
+            <a:ext cx="1737360" cy="1051560"/>
+          </a:xfrm>
+          <a:prstGeom prst="roundRect">
+            <a:avLst>
+              <a:gd name="adj" fmla="val 6957"/>
+            </a:avLst>
           </a:prstGeom>
           <a:solidFill>
             <a:srgbClr val="0F4C43"/>
@@ -5008,58 +5293,17 @@
       </p:sp>
       <p:sp>
         <p:nvSpPr>
-          <p:cNvPr id="38" name="Text 36"/>
-          <p:cNvSpPr txBox="1"/>
-          <p:nvPr/>
-        </p:nvSpPr>
-        <p:spPr>
-          <a:xfrm>
-            <a:off x="4078224" y="4873752"/>
-            <a:ext cx="1115568" cy="256032"/>
-          </a:xfrm>
-          <a:prstGeom prst="rect">
-            <a:avLst/>
-          </a:prstGeom>
-          <a:noFill/>
-          <a:ln/>
-        </p:spPr>
-        <p:txBody>
-          <a:bodyPr wrap="square" lIns="0" tIns="0" rIns="0" bIns="0" rtlCol="0" anchor="ctr"/>
-          <a:lstStyle/>
-          <a:p>
-            <a:pPr indent="0" marL="0">
-              <a:buNone/>
-            </a:pPr>
-            <a:r>
-              <a:rPr lang="en-US" sz="800" b="1" dirty="0">
-                <a:solidFill>
-                  <a:srgbClr val="9A6B0F"/>
-                </a:solidFill>
-                <a:latin typeface="Consolas" pitchFamily="34" charset="0"/>
-                <a:ea typeface="Consolas" pitchFamily="34" charset="-122"/>
-                <a:cs typeface="Consolas" pitchFamily="34" charset="-120"/>
-              </a:rPr>
-              <a:t>3 questions asked</a:t>
-            </a:r>
-            <a:endParaRPr lang="en-US" sz="800" dirty="0"/>
-          </a:p>
-        </p:txBody>
-      </p:sp>
-      <p:sp>
-        <p:nvSpPr>
-          <p:cNvPr id="39" name="Shape 37"/>
+          <p:cNvPr id="47" name="Shape 45"/>
           <p:cNvSpPr/>
           <p:nvPr/>
         </p:nvSpPr>
         <p:spPr>
           <a:xfrm>
-            <a:off x="5367528" y="2011680"/>
-            <a:ext cx="1481328" cy="1051560"/>
-          </a:xfrm>
-          <a:prstGeom prst="roundRect">
-            <a:avLst>
-              <a:gd name="adj" fmla="val 6957"/>
-            </a:avLst>
+            <a:off x="8050378" y="2953512"/>
+            <a:ext cx="1737360" cy="109728"/>
+          </a:xfrm>
+          <a:prstGeom prst="rect">
+            <a:avLst/>
           </a:prstGeom>
           <a:solidFill>
             <a:srgbClr val="0F4C43"/>
@@ -5074,17 +5318,264 @@
       </p:sp>
       <p:sp>
         <p:nvSpPr>
-          <p:cNvPr id="40" name="Shape 38"/>
+          <p:cNvPr id="48" name="Shape 46"/>
           <p:cNvSpPr/>
           <p:nvPr/>
         </p:nvSpPr>
         <p:spPr>
           <a:xfrm>
-            <a:off x="5367528" y="2953512"/>
-            <a:ext cx="1481328" cy="109728"/>
-          </a:xfrm>
-          <a:prstGeom prst="rect">
-            <a:avLst/>
+            <a:off x="8050378" y="3063240"/>
+            <a:ext cx="1737360" cy="2148840"/>
+          </a:xfrm>
+          <a:prstGeom prst="roundRect">
+            <a:avLst>
+              <a:gd name="adj" fmla="val 4211"/>
+            </a:avLst>
+          </a:prstGeom>
+          <a:solidFill>
+            <a:srgbClr val="F7FAF9"/>
+          </a:solidFill>
+          <a:ln w="12700">
+            <a:solidFill>
+              <a:srgbClr val="F7FAF9"/>
+            </a:solidFill>
+            <a:prstDash val="solid"/>
+          </a:ln>
+        </p:spPr>
+      </p:sp>
+      <p:sp>
+        <p:nvSpPr>
+          <p:cNvPr id="49" name="Shape 47"/>
+          <p:cNvSpPr/>
+          <p:nvPr/>
+        </p:nvSpPr>
+        <p:spPr>
+          <a:xfrm>
+            <a:off x="8050378" y="3063240"/>
+            <a:ext cx="1737360" cy="91440"/>
+          </a:xfrm>
+          <a:prstGeom prst="rect">
+            <a:avLst/>
+          </a:prstGeom>
+          <a:solidFill>
+            <a:srgbClr val="F7FAF9"/>
+          </a:solidFill>
+          <a:ln w="12700">
+            <a:solidFill>
+              <a:srgbClr val="F7FAF9"/>
+            </a:solidFill>
+            <a:prstDash val="solid"/>
+          </a:ln>
+        </p:spPr>
+      </p:sp>
+      <p:sp>
+        <p:nvSpPr>
+          <p:cNvPr id="50" name="Text 48"/>
+          <p:cNvSpPr txBox="1"/>
+          <p:nvPr/>
+        </p:nvSpPr>
+        <p:spPr>
+          <a:xfrm>
+            <a:off x="8214970" y="2112264"/>
+            <a:ext cx="1408176" cy="201168"/>
+          </a:xfrm>
+          <a:prstGeom prst="rect">
+            <a:avLst/>
+          </a:prstGeom>
+          <a:noFill/>
+          <a:ln/>
+        </p:spPr>
+        <p:txBody>
+          <a:bodyPr wrap="square" lIns="0" tIns="0" rIns="0" bIns="0" rtlCol="0" anchor="ctr"/>
+          <a:lstStyle/>
+          <a:p>
+            <a:pPr indent="0" marL="0">
+              <a:buNone/>
+            </a:pPr>
+            <a:r>
+              <a:rPr lang="en-US" sz="950" b="1" dirty="0">
+                <a:solidFill>
+                  <a:srgbClr val="8FC3B5"/>
+                </a:solidFill>
+                <a:latin typeface="Consolas" pitchFamily="34" charset="0"/>
+                <a:ea typeface="Consolas" pitchFamily="34" charset="-122"/>
+                <a:cs typeface="Consolas" pitchFamily="34" charset="-120"/>
+              </a:rPr>
+              <a:t>PHASE 5</a:t>
+            </a:r>
+            <a:endParaRPr lang="en-US" sz="950" dirty="0"/>
+          </a:p>
+        </p:txBody>
+      </p:sp>
+      <p:sp>
+        <p:nvSpPr>
+          <p:cNvPr id="51" name="Text 49"/>
+          <p:cNvSpPr txBox="1"/>
+          <p:nvPr/>
+        </p:nvSpPr>
+        <p:spPr>
+          <a:xfrm>
+            <a:off x="8214970" y="2304288"/>
+            <a:ext cx="1408176" cy="667512"/>
+          </a:xfrm>
+          <a:prstGeom prst="rect">
+            <a:avLst/>
+          </a:prstGeom>
+          <a:noFill/>
+          <a:ln/>
+        </p:spPr>
+        <p:txBody>
+          <a:bodyPr wrap="square" lIns="0" tIns="0" rIns="0" bIns="0" rtlCol="0" anchor="t"/>
+          <a:lstStyle/>
+          <a:p>
+            <a:pPr indent="0" marL="0">
+              <a:buNone/>
+            </a:pPr>
+            <a:r>
+              <a:rPr lang="en-US" sz="1400" b="1" dirty="0">
+                <a:solidFill>
+                  <a:srgbClr val="FFFFFF"/>
+                </a:solidFill>
+                <a:latin typeface="Cambria" pitchFamily="34" charset="0"/>
+                <a:ea typeface="Cambria" pitchFamily="34" charset="-122"/>
+                <a:cs typeface="Cambria" pitchFamily="34" charset="-120"/>
+              </a:rPr>
+              <a:t>Execution and budget</a:t>
+            </a:r>
+            <a:endParaRPr lang="en-US" sz="1400" dirty="0"/>
+          </a:p>
+        </p:txBody>
+      </p:sp>
+      <p:sp>
+        <p:nvSpPr>
+          <p:cNvPr id="52" name="Text 50"/>
+          <p:cNvSpPr txBox="1"/>
+          <p:nvPr/>
+        </p:nvSpPr>
+        <p:spPr>
+          <a:xfrm>
+            <a:off x="8196682" y="3191256"/>
+            <a:ext cx="1444752" cy="1892808"/>
+          </a:xfrm>
+          <a:prstGeom prst="rect">
+            <a:avLst/>
+          </a:prstGeom>
+          <a:noFill/>
+          <a:ln/>
+        </p:spPr>
+        <p:txBody>
+          <a:bodyPr wrap="square" lIns="0" tIns="0" rIns="0" bIns="0" rtlCol="0" anchor="t"/>
+          <a:lstStyle/>
+          <a:p>
+            <a:pPr indent="0" marL="0">
+              <a:spcAft>
+                <a:spcPts val="400"/>
+              </a:spcAft>
+              <a:buNone/>
+            </a:pPr>
+            <a:endParaRPr lang="en-US" sz="900" dirty="0"/>
+          </a:p>
+        </p:txBody>
+      </p:sp>
+      <p:sp>
+        <p:nvSpPr>
+          <p:cNvPr id="53" name="Text 51"/>
+          <p:cNvSpPr txBox="1"/>
+          <p:nvPr/>
+        </p:nvSpPr>
+        <p:spPr>
+          <a:xfrm>
+            <a:off x="8178394" y="3200400"/>
+            <a:ext cx="1481328" cy="1600200"/>
+          </a:xfrm>
+          <a:prstGeom prst="rect">
+            <a:avLst/>
+          </a:prstGeom>
+          <a:noFill/>
+          <a:ln/>
+        </p:spPr>
+        <p:txBody>
+          <a:bodyPr wrap="square" lIns="0" tIns="0" rIns="0" bIns="0" rtlCol="0" anchor="t"/>
+          <a:lstStyle/>
+          <a:p>
+            <a:pPr indent="0" marL="0">
+              <a:spcAft>
+                <a:spcPts val="600"/>
+              </a:spcAft>
+              <a:buNone/>
+            </a:pPr>
+            <a:r>
+              <a:rPr lang="en-US" sz="950" dirty="0">
+                <a:solidFill>
+                  <a:srgbClr val="16202B"/>
+                </a:solidFill>
+                <a:latin typeface="Calibri" pitchFamily="34" charset="0"/>
+                <a:ea typeface="Calibri" pitchFamily="34" charset="-122"/>
+                <a:cs typeface="Calibri" pitchFamily="34" charset="-120"/>
+              </a:rPr>
+              <a:t>Operations, governance, tasks, timeline and budget drafted on request; readiness recorded.</a:t>
+            </a:r>
+            <a:endParaRPr lang="en-US" sz="950" dirty="0"/>
+          </a:p>
+          <a:p>
+            <a:pPr indent="0" marL="0">
+              <a:buNone/>
+            </a:pPr>
+            <a:r>
+              <a:rPr lang="en-US" sz="950" b="1" dirty="0">
+                <a:solidFill>
+                  <a:srgbClr val="0F4C43"/>
+                </a:solidFill>
+                <a:latin typeface="Calibri" pitchFamily="34" charset="0"/>
+                <a:ea typeface="Calibri" pitchFamily="34" charset="-122"/>
+                <a:cs typeface="Calibri" pitchFamily="34" charset="-120"/>
+              </a:rPr>
+              <a:t>Gate: ready, conditional, or infeasible.</a:t>
+            </a:r>
+            <a:endParaRPr lang="en-US" sz="950" dirty="0"/>
+          </a:p>
+        </p:txBody>
+      </p:sp>
+      <p:sp>
+        <p:nvSpPr>
+          <p:cNvPr id="54" name="Shape 52"/>
+          <p:cNvSpPr/>
+          <p:nvPr/>
+        </p:nvSpPr>
+        <p:spPr>
+          <a:xfrm>
+            <a:off x="8178394" y="4937760"/>
+            <a:ext cx="118872" cy="118872"/>
+          </a:xfrm>
+          <a:prstGeom prst="rect">
+            <a:avLst/>
+          </a:prstGeom>
+          <a:solidFill>
+            <a:srgbClr val="D9AC5A"/>
+          </a:solidFill>
+          <a:ln w="12700">
+            <a:solidFill>
+              <a:srgbClr val="D9AC5A"/>
+            </a:solidFill>
+            <a:prstDash val="solid"/>
+          </a:ln>
+        </p:spPr>
+      </p:sp>
+      <p:sp>
+        <p:nvSpPr>
+          <p:cNvPr id="55" name="Shape 53"/>
+          <p:cNvSpPr/>
+          <p:nvPr/>
+        </p:nvSpPr>
+        <p:spPr>
+          <a:xfrm>
+            <a:off x="9921240" y="2011680"/>
+            <a:ext cx="1737360" cy="1051560"/>
+          </a:xfrm>
+          <a:prstGeom prst="roundRect">
+            <a:avLst>
+              <a:gd name="adj" fmla="val 6957"/>
+            </a:avLst>
           </a:prstGeom>
           <a:solidFill>
             <a:srgbClr val="0F4C43"/>
@@ -5099,18 +5590,43 @@
       </p:sp>
       <p:sp>
         <p:nvSpPr>
-          <p:cNvPr id="41" name="Shape 39"/>
+          <p:cNvPr id="56" name="Shape 54"/>
           <p:cNvSpPr/>
           <p:nvPr/>
         </p:nvSpPr>
         <p:spPr>
           <a:xfrm>
-            <a:off x="5367528" y="3063240"/>
-            <a:ext cx="1481328" cy="2148840"/>
+            <a:off x="9921240" y="2953512"/>
+            <a:ext cx="1737360" cy="109728"/>
+          </a:xfrm>
+          <a:prstGeom prst="rect">
+            <a:avLst/>
+          </a:prstGeom>
+          <a:solidFill>
+            <a:srgbClr val="0F4C43"/>
+          </a:solidFill>
+          <a:ln w="12700">
+            <a:solidFill>
+              <a:srgbClr val="0F4C43"/>
+            </a:solidFill>
+            <a:prstDash val="solid"/>
+          </a:ln>
+        </p:spPr>
+      </p:sp>
+      <p:sp>
+        <p:nvSpPr>
+          <p:cNvPr id="57" name="Shape 55"/>
+          <p:cNvSpPr/>
+          <p:nvPr/>
+        </p:nvSpPr>
+        <p:spPr>
+          <a:xfrm>
+            <a:off x="9921240" y="3063240"/>
+            <a:ext cx="1737360" cy="2148840"/>
           </a:xfrm>
           <a:prstGeom prst="roundRect">
             <a:avLst>
-              <a:gd name="adj" fmla="val 4938"/>
+              <a:gd name="adj" fmla="val 4211"/>
             </a:avLst>
           </a:prstGeom>
           <a:solidFill>
@@ -5126,14 +5642,14 @@
       </p:sp>
       <p:sp>
         <p:nvSpPr>
-          <p:cNvPr id="42" name="Shape 40"/>
+          <p:cNvPr id="58" name="Shape 56"/>
           <p:cNvSpPr/>
           <p:nvPr/>
         </p:nvSpPr>
         <p:spPr>
           <a:xfrm>
-            <a:off x="5367528" y="3063240"/>
-            <a:ext cx="1481328" cy="91440"/>
+            <a:off x="9921240" y="3063240"/>
+            <a:ext cx="1737360" cy="91440"/>
           </a:xfrm>
           <a:prstGeom prst="rect">
             <a:avLst/>
@@ -5151,14 +5667,14 @@
       </p:sp>
       <p:sp>
         <p:nvSpPr>
-          <p:cNvPr id="43" name="Text 41"/>
-          <p:cNvSpPr txBox="1"/>
-          <p:nvPr/>
-        </p:nvSpPr>
-        <p:spPr>
-          <a:xfrm>
-            <a:off x="5532120" y="2112264"/>
-            <a:ext cx="1152144" cy="201168"/>
+          <p:cNvPr id="59" name="Text 57"/>
+          <p:cNvSpPr txBox="1"/>
+          <p:nvPr/>
+        </p:nvSpPr>
+        <p:spPr>
+          <a:xfrm>
+            <a:off x="10085832" y="2112264"/>
+            <a:ext cx="1408176" cy="201168"/>
           </a:xfrm>
           <a:prstGeom prst="rect">
             <a:avLst/>
@@ -5182,7 +5698,7 @@
                 <a:ea typeface="Consolas" pitchFamily="34" charset="-122"/>
                 <a:cs typeface="Consolas" pitchFamily="34" charset="-120"/>
               </a:rPr>
-              <a:t>STEP 4</a:t>
+              <a:t>PHASE 6</a:t>
             </a:r>
             <a:endParaRPr lang="en-US" sz="950" dirty="0"/>
           </a:p>
@@ -5190,14 +5706,14 @@
       </p:sp>
       <p:sp>
         <p:nvSpPr>
-          <p:cNvPr id="44" name="Text 42"/>
-          <p:cNvSpPr txBox="1"/>
-          <p:nvPr/>
-        </p:nvSpPr>
-        <p:spPr>
-          <a:xfrm>
-            <a:off x="5532120" y="2304288"/>
-            <a:ext cx="1152144" cy="667512"/>
+          <p:cNvPr id="60" name="Text 58"/>
+          <p:cNvSpPr txBox="1"/>
+          <p:nvPr/>
+        </p:nvSpPr>
+        <p:spPr>
+          <a:xfrm>
+            <a:off x="10085832" y="2304288"/>
+            <a:ext cx="1408176" cy="667512"/>
           </a:xfrm>
           <a:prstGeom prst="rect">
             <a:avLst/>
@@ -5221,7 +5737,7 @@
                 <a:ea typeface="Cambria" pitchFamily="34" charset="-122"/>
                 <a:cs typeface="Cambria" pitchFamily="34" charset="-120"/>
               </a:rPr>
-              <a:t>Analysis and how many</a:t>
+              <a:t>Finalise and export</a:t>
             </a:r>
             <a:endParaRPr lang="en-US" sz="1400" dirty="0"/>
           </a:p>
@@ -5229,14 +5745,14 @@
       </p:sp>
       <p:sp>
         <p:nvSpPr>
-          <p:cNvPr id="45" name="Text 43"/>
-          <p:cNvSpPr txBox="1"/>
-          <p:nvPr/>
-        </p:nvSpPr>
-        <p:spPr>
-          <a:xfrm>
-            <a:off x="5513832" y="3191256"/>
-            <a:ext cx="1188720" cy="1892808"/>
+          <p:cNvPr id="61" name="Text 59"/>
+          <p:cNvSpPr txBox="1"/>
+          <p:nvPr/>
+        </p:nvSpPr>
+        <p:spPr>
+          <a:xfrm>
+            <a:off x="10067544" y="3191256"/>
+            <a:ext cx="1444752" cy="1892808"/>
           </a:xfrm>
           <a:prstGeom prst="rect">
             <a:avLst/>
@@ -5260,14 +5776,14 @@
       </p:sp>
       <p:sp>
         <p:nvSpPr>
-          <p:cNvPr id="46" name="Text 44"/>
-          <p:cNvSpPr txBox="1"/>
-          <p:nvPr/>
-        </p:nvSpPr>
-        <p:spPr>
-          <a:xfrm>
-            <a:off x="5495544" y="3200400"/>
-            <a:ext cx="1225296" cy="1463040"/>
+          <p:cNvPr id="62" name="Text 60"/>
+          <p:cNvSpPr txBox="1"/>
+          <p:nvPr/>
+        </p:nvSpPr>
+        <p:spPr>
+          <a:xfrm>
+            <a:off x="10049256" y="3200400"/>
+            <a:ext cx="1481328" cy="1600200"/>
           </a:xfrm>
           <a:prstGeom prst="rect">
             <a:avLst/>
@@ -5294,7 +5810,7 @@
                 <a:ea typeface="Calibri" pitchFamily="34" charset="-122"/>
                 <a:cs typeface="Calibri" pitchFamily="34" charset="-120"/>
               </a:rPr>
-              <a:t>How the numbers are compared, and how many patients that takes.</a:t>
+              <a:t>Written package and code per language on request; reconciler named; export with review record.</a:t>
             </a:r>
             <a:endParaRPr lang="en-US" sz="950" dirty="0"/>
           </a:p>
@@ -5311,7 +5827,7 @@
                 <a:ea typeface="Calibri" pitchFamily="34" charset="-122"/>
                 <a:cs typeface="Calibri" pitchFamily="34" charset="-120"/>
               </a:rPr>
-              <a:t>Two-lab review, corrective pass, adjudication.</a:t>
+              <a:t>Gate: nothing pending, no open comments.</a:t>
             </a:r>
             <a:endParaRPr lang="en-US" sz="950" dirty="0"/>
           </a:p>
@@ -5319,24 +5835,24 @@
       </p:sp>
       <p:sp>
         <p:nvSpPr>
-          <p:cNvPr id="47" name="Shape 45"/>
+          <p:cNvPr id="63" name="Shape 61"/>
           <p:cNvSpPr/>
           <p:nvPr/>
         </p:nvSpPr>
         <p:spPr>
           <a:xfrm>
-            <a:off x="5495544" y="4937760"/>
+            <a:off x="10049256" y="4937760"/>
             <a:ext cx="118872" cy="118872"/>
           </a:xfrm>
           <a:prstGeom prst="rect">
             <a:avLst/>
           </a:prstGeom>
           <a:solidFill>
-            <a:srgbClr val="9A6B0F"/>
+            <a:srgbClr val="D9AC5A"/>
           </a:solidFill>
           <a:ln w="12700">
             <a:solidFill>
-              <a:srgbClr val="9A6B0F"/>
+              <a:srgbClr val="D9AC5A"/>
             </a:solidFill>
             <a:prstDash val="solid"/>
           </a:ln>
@@ -5344,937 +5860,7 @@
       </p:sp>
       <p:sp>
         <p:nvSpPr>
-          <p:cNvPr id="48" name="Text 46"/>
-          <p:cNvSpPr txBox="1"/>
-          <p:nvPr/>
-        </p:nvSpPr>
-        <p:spPr>
-          <a:xfrm>
-            <a:off x="5678424" y="4873752"/>
-            <a:ext cx="1115568" cy="256032"/>
-          </a:xfrm>
-          <a:prstGeom prst="rect">
-            <a:avLst/>
-          </a:prstGeom>
-          <a:noFill/>
-          <a:ln/>
-        </p:spPr>
-        <p:txBody>
-          <a:bodyPr wrap="square" lIns="0" tIns="0" rIns="0" bIns="0" rtlCol="0" anchor="ctr"/>
-          <a:lstStyle/>
-          <a:p>
-            <a:pPr indent="0" marL="0">
-              <a:buNone/>
-            </a:pPr>
-            <a:r>
-              <a:rPr lang="en-US" sz="800" b="1" dirty="0">
-                <a:solidFill>
-                  <a:srgbClr val="9A6B0F"/>
-                </a:solidFill>
-                <a:latin typeface="Consolas" pitchFamily="34" charset="0"/>
-                <a:ea typeface="Consolas" pitchFamily="34" charset="-122"/>
-                <a:cs typeface="Consolas" pitchFamily="34" charset="-120"/>
-              </a:rPr>
-              <a:t>1 question asked</a:t>
-            </a:r>
-            <a:endParaRPr lang="en-US" sz="800" dirty="0"/>
-          </a:p>
-        </p:txBody>
-      </p:sp>
-      <p:sp>
-        <p:nvSpPr>
-          <p:cNvPr id="49" name="Shape 47"/>
-          <p:cNvSpPr/>
-          <p:nvPr/>
-        </p:nvSpPr>
-        <p:spPr>
-          <a:xfrm>
-            <a:off x="6967728" y="2011680"/>
-            <a:ext cx="1481328" cy="1051560"/>
-          </a:xfrm>
-          <a:prstGeom prst="roundRect">
-            <a:avLst>
-              <a:gd name="adj" fmla="val 6957"/>
-            </a:avLst>
-          </a:prstGeom>
-          <a:solidFill>
-            <a:srgbClr val="0F4C43"/>
-          </a:solidFill>
-          <a:ln w="12700">
-            <a:solidFill>
-              <a:srgbClr val="0F4C43"/>
-            </a:solidFill>
-            <a:prstDash val="solid"/>
-          </a:ln>
-        </p:spPr>
-      </p:sp>
-      <p:sp>
-        <p:nvSpPr>
-          <p:cNvPr id="50" name="Shape 48"/>
-          <p:cNvSpPr/>
-          <p:nvPr/>
-        </p:nvSpPr>
-        <p:spPr>
-          <a:xfrm>
-            <a:off x="6967728" y="2953512"/>
-            <a:ext cx="1481328" cy="109728"/>
-          </a:xfrm>
-          <a:prstGeom prst="rect">
-            <a:avLst/>
-          </a:prstGeom>
-          <a:solidFill>
-            <a:srgbClr val="0F4C43"/>
-          </a:solidFill>
-          <a:ln w="12700">
-            <a:solidFill>
-              <a:srgbClr val="0F4C43"/>
-            </a:solidFill>
-            <a:prstDash val="solid"/>
-          </a:ln>
-        </p:spPr>
-      </p:sp>
-      <p:sp>
-        <p:nvSpPr>
-          <p:cNvPr id="51" name="Shape 49"/>
-          <p:cNvSpPr/>
-          <p:nvPr/>
-        </p:nvSpPr>
-        <p:spPr>
-          <a:xfrm>
-            <a:off x="6967728" y="3063240"/>
-            <a:ext cx="1481328" cy="2148840"/>
-          </a:xfrm>
-          <a:prstGeom prst="roundRect">
-            <a:avLst>
-              <a:gd name="adj" fmla="val 4938"/>
-            </a:avLst>
-          </a:prstGeom>
-          <a:solidFill>
-            <a:srgbClr val="F7FAF9"/>
-          </a:solidFill>
-          <a:ln w="12700">
-            <a:solidFill>
-              <a:srgbClr val="F7FAF9"/>
-            </a:solidFill>
-            <a:prstDash val="solid"/>
-          </a:ln>
-        </p:spPr>
-      </p:sp>
-      <p:sp>
-        <p:nvSpPr>
-          <p:cNvPr id="52" name="Shape 50"/>
-          <p:cNvSpPr/>
-          <p:nvPr/>
-        </p:nvSpPr>
-        <p:spPr>
-          <a:xfrm>
-            <a:off x="6967728" y="3063240"/>
-            <a:ext cx="1481328" cy="91440"/>
-          </a:xfrm>
-          <a:prstGeom prst="rect">
-            <a:avLst/>
-          </a:prstGeom>
-          <a:solidFill>
-            <a:srgbClr val="F7FAF9"/>
-          </a:solidFill>
-          <a:ln w="12700">
-            <a:solidFill>
-              <a:srgbClr val="F7FAF9"/>
-            </a:solidFill>
-            <a:prstDash val="solid"/>
-          </a:ln>
-        </p:spPr>
-      </p:sp>
-      <p:sp>
-        <p:nvSpPr>
-          <p:cNvPr id="53" name="Text 51"/>
-          <p:cNvSpPr txBox="1"/>
-          <p:nvPr/>
-        </p:nvSpPr>
-        <p:spPr>
-          <a:xfrm>
-            <a:off x="7132320" y="2112264"/>
-            <a:ext cx="1152144" cy="201168"/>
-          </a:xfrm>
-          <a:prstGeom prst="rect">
-            <a:avLst/>
-          </a:prstGeom>
-          <a:noFill/>
-          <a:ln/>
-        </p:spPr>
-        <p:txBody>
-          <a:bodyPr wrap="square" lIns="0" tIns="0" rIns="0" bIns="0" rtlCol="0" anchor="ctr"/>
-          <a:lstStyle/>
-          <a:p>
-            <a:pPr indent="0" marL="0">
-              <a:buNone/>
-            </a:pPr>
-            <a:r>
-              <a:rPr lang="en-US" sz="950" b="1" dirty="0">
-                <a:solidFill>
-                  <a:srgbClr val="8FC3B5"/>
-                </a:solidFill>
-                <a:latin typeface="Consolas" pitchFamily="34" charset="0"/>
-                <a:ea typeface="Consolas" pitchFamily="34" charset="-122"/>
-                <a:cs typeface="Consolas" pitchFamily="34" charset="-120"/>
-              </a:rPr>
-              <a:t>STEP 5</a:t>
-            </a:r>
-            <a:endParaRPr lang="en-US" sz="950" dirty="0"/>
-          </a:p>
-        </p:txBody>
-      </p:sp>
-      <p:sp>
-        <p:nvSpPr>
-          <p:cNvPr id="54" name="Text 52"/>
-          <p:cNvSpPr txBox="1"/>
-          <p:nvPr/>
-        </p:nvSpPr>
-        <p:spPr>
-          <a:xfrm>
-            <a:off x="7132320" y="2304288"/>
-            <a:ext cx="1152144" cy="667512"/>
-          </a:xfrm>
-          <a:prstGeom prst="rect">
-            <a:avLst/>
-          </a:prstGeom>
-          <a:noFill/>
-          <a:ln/>
-        </p:spPr>
-        <p:txBody>
-          <a:bodyPr wrap="square" lIns="0" tIns="0" rIns="0" bIns="0" rtlCol="0" anchor="t"/>
-          <a:lstStyle/>
-          <a:p>
-            <a:pPr indent="0" marL="0">
-              <a:buNone/>
-            </a:pPr>
-            <a:r>
-              <a:rPr lang="en-US" sz="1400" b="1" dirty="0">
-                <a:solidFill>
-                  <a:srgbClr val="FFFFFF"/>
-                </a:solidFill>
-                <a:latin typeface="Cambria" pitchFamily="34" charset="0"/>
-                <a:ea typeface="Cambria" pitchFamily="34" charset="-122"/>
-                <a:cs typeface="Cambria" pitchFamily="34" charset="-120"/>
-              </a:rPr>
-              <a:t>Approvals, team, cost</a:t>
-            </a:r>
-            <a:endParaRPr lang="en-US" sz="1400" dirty="0"/>
-          </a:p>
-        </p:txBody>
-      </p:sp>
-      <p:sp>
-        <p:nvSpPr>
-          <p:cNvPr id="55" name="Text 53"/>
-          <p:cNvSpPr txBox="1"/>
-          <p:nvPr/>
-        </p:nvSpPr>
-        <p:spPr>
-          <a:xfrm>
-            <a:off x="7114032" y="3191256"/>
-            <a:ext cx="1188720" cy="1892808"/>
-          </a:xfrm>
-          <a:prstGeom prst="rect">
-            <a:avLst/>
-          </a:prstGeom>
-          <a:noFill/>
-          <a:ln/>
-        </p:spPr>
-        <p:txBody>
-          <a:bodyPr wrap="square" lIns="0" tIns="0" rIns="0" bIns="0" rtlCol="0" anchor="t"/>
-          <a:lstStyle/>
-          <a:p>
-            <a:pPr indent="0" marL="0">
-              <a:spcAft>
-                <a:spcPts val="400"/>
-              </a:spcAft>
-              <a:buNone/>
-            </a:pPr>
-            <a:endParaRPr lang="en-US" sz="900" dirty="0"/>
-          </a:p>
-        </p:txBody>
-      </p:sp>
-      <p:sp>
-        <p:nvSpPr>
-          <p:cNvPr id="56" name="Text 54"/>
-          <p:cNvSpPr txBox="1"/>
-          <p:nvPr/>
-        </p:nvSpPr>
-        <p:spPr>
-          <a:xfrm>
-            <a:off x="7095744" y="3200400"/>
-            <a:ext cx="1225296" cy="1463040"/>
-          </a:xfrm>
-          <a:prstGeom prst="rect">
-            <a:avLst/>
-          </a:prstGeom>
-          <a:noFill/>
-          <a:ln/>
-        </p:spPr>
-        <p:txBody>
-          <a:bodyPr wrap="square" lIns="0" tIns="0" rIns="0" bIns="0" rtlCol="0" anchor="t"/>
-          <a:lstStyle/>
-          <a:p>
-            <a:pPr indent="0" marL="0">
-              <a:spcAft>
-                <a:spcPts val="600"/>
-              </a:spcAft>
-              <a:buNone/>
-            </a:pPr>
-            <a:r>
-              <a:rPr lang="en-US" sz="950" dirty="0">
-                <a:solidFill>
-                  <a:srgbClr val="16202B"/>
-                </a:solidFill>
-                <a:latin typeface="Calibri" pitchFamily="34" charset="0"/>
-                <a:ea typeface="Calibri" pitchFamily="34" charset="-122"/>
-                <a:cs typeface="Calibri" pitchFamily="34" charset="-120"/>
-              </a:rPr>
-              <a:t>Who approves, what it costs, what to do on Monday.</a:t>
-            </a:r>
-            <a:endParaRPr lang="en-US" sz="950" dirty="0"/>
-          </a:p>
-          <a:p>
-            <a:pPr indent="0" marL="0">
-              <a:buNone/>
-            </a:pPr>
-            <a:r>
-              <a:rPr lang="en-US" sz="950" b="1" dirty="0">
-                <a:solidFill>
-                  <a:srgbClr val="0F4C43"/>
-                </a:solidFill>
-                <a:latin typeface="Calibri" pitchFamily="34" charset="0"/>
-                <a:ea typeface="Calibri" pitchFamily="34" charset="-122"/>
-                <a:cs typeface="Calibri" pitchFamily="34" charset="-120"/>
-              </a:rPr>
-              <a:t>Runs on its own after step 4.</a:t>
-            </a:r>
-            <a:endParaRPr lang="en-US" sz="950" dirty="0"/>
-          </a:p>
-        </p:txBody>
-      </p:sp>
-      <p:sp>
-        <p:nvSpPr>
-          <p:cNvPr id="57" name="Shape 55"/>
-          <p:cNvSpPr/>
-          <p:nvPr/>
-        </p:nvSpPr>
-        <p:spPr>
-          <a:xfrm>
-            <a:off x="7095744" y="4937760"/>
-            <a:ext cx="118872" cy="118872"/>
-          </a:xfrm>
-          <a:prstGeom prst="rect">
-            <a:avLst/>
-          </a:prstGeom>
-          <a:solidFill>
-            <a:srgbClr val="0F4C43"/>
-          </a:solidFill>
-          <a:ln w="12700">
-            <a:solidFill>
-              <a:srgbClr val="0F4C43"/>
-            </a:solidFill>
-            <a:prstDash val="solid"/>
-          </a:ln>
-        </p:spPr>
-      </p:sp>
-      <p:sp>
-        <p:nvSpPr>
-          <p:cNvPr id="58" name="Shape 56"/>
-          <p:cNvSpPr/>
-          <p:nvPr/>
-        </p:nvSpPr>
-        <p:spPr>
-          <a:xfrm>
-            <a:off x="8567928" y="2011680"/>
-            <a:ext cx="1481328" cy="1051560"/>
-          </a:xfrm>
-          <a:prstGeom prst="roundRect">
-            <a:avLst>
-              <a:gd name="adj" fmla="val 6957"/>
-            </a:avLst>
-          </a:prstGeom>
-          <a:solidFill>
-            <a:srgbClr val="0F4C43"/>
-          </a:solidFill>
-          <a:ln w="12700">
-            <a:solidFill>
-              <a:srgbClr val="0F4C43"/>
-            </a:solidFill>
-            <a:prstDash val="solid"/>
-          </a:ln>
-        </p:spPr>
-      </p:sp>
-      <p:sp>
-        <p:nvSpPr>
-          <p:cNvPr id="59" name="Shape 57"/>
-          <p:cNvSpPr/>
-          <p:nvPr/>
-        </p:nvSpPr>
-        <p:spPr>
-          <a:xfrm>
-            <a:off x="8567928" y="2953512"/>
-            <a:ext cx="1481328" cy="109728"/>
-          </a:xfrm>
-          <a:prstGeom prst="rect">
-            <a:avLst/>
-          </a:prstGeom>
-          <a:solidFill>
-            <a:srgbClr val="0F4C43"/>
-          </a:solidFill>
-          <a:ln w="12700">
-            <a:solidFill>
-              <a:srgbClr val="0F4C43"/>
-            </a:solidFill>
-            <a:prstDash val="solid"/>
-          </a:ln>
-        </p:spPr>
-      </p:sp>
-      <p:sp>
-        <p:nvSpPr>
-          <p:cNvPr id="60" name="Shape 58"/>
-          <p:cNvSpPr/>
-          <p:nvPr/>
-        </p:nvSpPr>
-        <p:spPr>
-          <a:xfrm>
-            <a:off x="8567928" y="3063240"/>
-            <a:ext cx="1481328" cy="2148840"/>
-          </a:xfrm>
-          <a:prstGeom prst="roundRect">
-            <a:avLst>
-              <a:gd name="adj" fmla="val 4938"/>
-            </a:avLst>
-          </a:prstGeom>
-          <a:solidFill>
-            <a:srgbClr val="F7FAF9"/>
-          </a:solidFill>
-          <a:ln w="12700">
-            <a:solidFill>
-              <a:srgbClr val="F7FAF9"/>
-            </a:solidFill>
-            <a:prstDash val="solid"/>
-          </a:ln>
-        </p:spPr>
-      </p:sp>
-      <p:sp>
-        <p:nvSpPr>
-          <p:cNvPr id="61" name="Shape 59"/>
-          <p:cNvSpPr/>
-          <p:nvPr/>
-        </p:nvSpPr>
-        <p:spPr>
-          <a:xfrm>
-            <a:off x="8567928" y="3063240"/>
-            <a:ext cx="1481328" cy="91440"/>
-          </a:xfrm>
-          <a:prstGeom prst="rect">
-            <a:avLst/>
-          </a:prstGeom>
-          <a:solidFill>
-            <a:srgbClr val="F7FAF9"/>
-          </a:solidFill>
-          <a:ln w="12700">
-            <a:solidFill>
-              <a:srgbClr val="F7FAF9"/>
-            </a:solidFill>
-            <a:prstDash val="solid"/>
-          </a:ln>
-        </p:spPr>
-      </p:sp>
-      <p:sp>
-        <p:nvSpPr>
-          <p:cNvPr id="62" name="Text 60"/>
-          <p:cNvSpPr txBox="1"/>
-          <p:nvPr/>
-        </p:nvSpPr>
-        <p:spPr>
-          <a:xfrm>
-            <a:off x="8732520" y="2112264"/>
-            <a:ext cx="1152144" cy="201168"/>
-          </a:xfrm>
-          <a:prstGeom prst="rect">
-            <a:avLst/>
-          </a:prstGeom>
-          <a:noFill/>
-          <a:ln/>
-        </p:spPr>
-        <p:txBody>
-          <a:bodyPr wrap="square" lIns="0" tIns="0" rIns="0" bIns="0" rtlCol="0" anchor="ctr"/>
-          <a:lstStyle/>
-          <a:p>
-            <a:pPr indent="0" marL="0">
-              <a:buNone/>
-            </a:pPr>
-            <a:r>
-              <a:rPr lang="en-US" sz="950" b="1" dirty="0">
-                <a:solidFill>
-                  <a:srgbClr val="8FC3B5"/>
-                </a:solidFill>
-                <a:latin typeface="Consolas" pitchFamily="34" charset="0"/>
-                <a:ea typeface="Consolas" pitchFamily="34" charset="-122"/>
-                <a:cs typeface="Consolas" pitchFamily="34" charset="-120"/>
-              </a:rPr>
-              <a:t>STEP 6</a:t>
-            </a:r>
-            <a:endParaRPr lang="en-US" sz="950" dirty="0"/>
-          </a:p>
-        </p:txBody>
-      </p:sp>
-      <p:sp>
-        <p:nvSpPr>
-          <p:cNvPr id="63" name="Text 61"/>
-          <p:cNvSpPr txBox="1"/>
-          <p:nvPr/>
-        </p:nvSpPr>
-        <p:spPr>
-          <a:xfrm>
-            <a:off x="8732520" y="2304288"/>
-            <a:ext cx="1152144" cy="667512"/>
-          </a:xfrm>
-          <a:prstGeom prst="rect">
-            <a:avLst/>
-          </a:prstGeom>
-          <a:noFill/>
-          <a:ln/>
-        </p:spPr>
-        <p:txBody>
-          <a:bodyPr wrap="square" lIns="0" tIns="0" rIns="0" bIns="0" rtlCol="0" anchor="t"/>
-          <a:lstStyle/>
-          <a:p>
-            <a:pPr indent="0" marL="0">
-              <a:buNone/>
-            </a:pPr>
-            <a:r>
-              <a:rPr lang="en-US" sz="1400" b="1" dirty="0">
-                <a:solidFill>
-                  <a:srgbClr val="FFFFFF"/>
-                </a:solidFill>
-                <a:latin typeface="Cambria" pitchFamily="34" charset="0"/>
-                <a:ea typeface="Cambria" pitchFamily="34" charset="-122"/>
-                <a:cs typeface="Cambria" pitchFamily="34" charset="-120"/>
-              </a:rPr>
-              <a:t>Write-up</a:t>
-            </a:r>
-            <a:endParaRPr lang="en-US" sz="1400" dirty="0"/>
-          </a:p>
-        </p:txBody>
-      </p:sp>
-      <p:sp>
-        <p:nvSpPr>
-          <p:cNvPr id="64" name="Text 62"/>
-          <p:cNvSpPr txBox="1"/>
-          <p:nvPr/>
-        </p:nvSpPr>
-        <p:spPr>
-          <a:xfrm>
-            <a:off x="8714232" y="3191256"/>
-            <a:ext cx="1188720" cy="1892808"/>
-          </a:xfrm>
-          <a:prstGeom prst="rect">
-            <a:avLst/>
-          </a:prstGeom>
-          <a:noFill/>
-          <a:ln/>
-        </p:spPr>
-        <p:txBody>
-          <a:bodyPr wrap="square" lIns="0" tIns="0" rIns="0" bIns="0" rtlCol="0" anchor="t"/>
-          <a:lstStyle/>
-          <a:p>
-            <a:pPr indent="0" marL="0">
-              <a:spcAft>
-                <a:spcPts val="400"/>
-              </a:spcAft>
-              <a:buNone/>
-            </a:pPr>
-            <a:endParaRPr lang="en-US" sz="900" dirty="0"/>
-          </a:p>
-        </p:txBody>
-      </p:sp>
-      <p:sp>
-        <p:nvSpPr>
-          <p:cNvPr id="65" name="Text 63"/>
-          <p:cNvSpPr txBox="1"/>
-          <p:nvPr/>
-        </p:nvSpPr>
-        <p:spPr>
-          <a:xfrm>
-            <a:off x="8695944" y="3200400"/>
-            <a:ext cx="1225296" cy="1463040"/>
-          </a:xfrm>
-          <a:prstGeom prst="rect">
-            <a:avLst/>
-          </a:prstGeom>
-          <a:noFill/>
-          <a:ln/>
-        </p:spPr>
-        <p:txBody>
-          <a:bodyPr wrap="square" lIns="0" tIns="0" rIns="0" bIns="0" rtlCol="0" anchor="t"/>
-          <a:lstStyle/>
-          <a:p>
-            <a:pPr indent="0" marL="0">
-              <a:spcAft>
-                <a:spcPts val="600"/>
-              </a:spcAft>
-              <a:buNone/>
-            </a:pPr>
-            <a:r>
-              <a:rPr lang="en-US" sz="950" dirty="0">
-                <a:solidFill>
-                  <a:srgbClr val="16202B"/>
-                </a:solidFill>
-                <a:latin typeface="Calibri" pitchFamily="34" charset="0"/>
-                <a:ea typeface="Calibri" pitchFamily="34" charset="-122"/>
-                <a:cs typeface="Calibri" pitchFamily="34" charset="-120"/>
-              </a:rPr>
-              <a:t>Abstract, methods paragraph, background with PubMed-resolved references.</a:t>
-            </a:r>
-            <a:endParaRPr lang="en-US" sz="950" dirty="0"/>
-          </a:p>
-          <a:p>
-            <a:pPr indent="0" marL="0">
-              <a:buNone/>
-            </a:pPr>
-            <a:r>
-              <a:rPr lang="en-US" sz="950" b="1" dirty="0">
-                <a:solidFill>
-                  <a:srgbClr val="0F4C43"/>
-                </a:solidFill>
-                <a:latin typeface="Calibri" pitchFamily="34" charset="0"/>
-                <a:ea typeface="Calibri" pitchFamily="34" charset="-122"/>
-                <a:cs typeface="Calibri" pitchFamily="34" charset="-120"/>
-              </a:rPr>
-              <a:t>On request.</a:t>
-            </a:r>
-            <a:endParaRPr lang="en-US" sz="950" dirty="0"/>
-          </a:p>
-        </p:txBody>
-      </p:sp>
-      <p:sp>
-        <p:nvSpPr>
-          <p:cNvPr id="66" name="Shape 64"/>
-          <p:cNvSpPr/>
-          <p:nvPr/>
-        </p:nvSpPr>
-        <p:spPr>
-          <a:xfrm>
-            <a:off x="8695944" y="4937760"/>
-            <a:ext cx="118872" cy="118872"/>
-          </a:xfrm>
-          <a:prstGeom prst="rect">
-            <a:avLst/>
-          </a:prstGeom>
-          <a:solidFill>
-            <a:srgbClr val="0F4C43"/>
-          </a:solidFill>
-          <a:ln w="12700">
-            <a:solidFill>
-              <a:srgbClr val="0F4C43"/>
-            </a:solidFill>
-            <a:prstDash val="solid"/>
-          </a:ln>
-        </p:spPr>
-      </p:sp>
-      <p:sp>
-        <p:nvSpPr>
-          <p:cNvPr id="67" name="Shape 65"/>
-          <p:cNvSpPr/>
-          <p:nvPr/>
-        </p:nvSpPr>
-        <p:spPr>
-          <a:xfrm>
-            <a:off x="10168128" y="2011680"/>
-            <a:ext cx="1481328" cy="1051560"/>
-          </a:xfrm>
-          <a:prstGeom prst="roundRect">
-            <a:avLst>
-              <a:gd name="adj" fmla="val 6957"/>
-            </a:avLst>
-          </a:prstGeom>
-          <a:solidFill>
-            <a:srgbClr val="0F4C43"/>
-          </a:solidFill>
-          <a:ln w="12700">
-            <a:solidFill>
-              <a:srgbClr val="0F4C43"/>
-            </a:solidFill>
-            <a:prstDash val="solid"/>
-          </a:ln>
-        </p:spPr>
-      </p:sp>
-      <p:sp>
-        <p:nvSpPr>
-          <p:cNvPr id="68" name="Shape 66"/>
-          <p:cNvSpPr/>
-          <p:nvPr/>
-        </p:nvSpPr>
-        <p:spPr>
-          <a:xfrm>
-            <a:off x="10168128" y="2953512"/>
-            <a:ext cx="1481328" cy="109728"/>
-          </a:xfrm>
-          <a:prstGeom prst="rect">
-            <a:avLst/>
-          </a:prstGeom>
-          <a:solidFill>
-            <a:srgbClr val="0F4C43"/>
-          </a:solidFill>
-          <a:ln w="12700">
-            <a:solidFill>
-              <a:srgbClr val="0F4C43"/>
-            </a:solidFill>
-            <a:prstDash val="solid"/>
-          </a:ln>
-        </p:spPr>
-      </p:sp>
-      <p:sp>
-        <p:nvSpPr>
-          <p:cNvPr id="69" name="Shape 67"/>
-          <p:cNvSpPr/>
-          <p:nvPr/>
-        </p:nvSpPr>
-        <p:spPr>
-          <a:xfrm>
-            <a:off x="10168128" y="3063240"/>
-            <a:ext cx="1481328" cy="2148840"/>
-          </a:xfrm>
-          <a:prstGeom prst="roundRect">
-            <a:avLst>
-              <a:gd name="adj" fmla="val 4938"/>
-            </a:avLst>
-          </a:prstGeom>
-          <a:solidFill>
-            <a:srgbClr val="F7FAF9"/>
-          </a:solidFill>
-          <a:ln w="12700">
-            <a:solidFill>
-              <a:srgbClr val="F7FAF9"/>
-            </a:solidFill>
-            <a:prstDash val="solid"/>
-          </a:ln>
-        </p:spPr>
-      </p:sp>
-      <p:sp>
-        <p:nvSpPr>
-          <p:cNvPr id="70" name="Shape 68"/>
-          <p:cNvSpPr/>
-          <p:nvPr/>
-        </p:nvSpPr>
-        <p:spPr>
-          <a:xfrm>
-            <a:off x="10168128" y="3063240"/>
-            <a:ext cx="1481328" cy="91440"/>
-          </a:xfrm>
-          <a:prstGeom prst="rect">
-            <a:avLst/>
-          </a:prstGeom>
-          <a:solidFill>
-            <a:srgbClr val="F7FAF9"/>
-          </a:solidFill>
-          <a:ln w="12700">
-            <a:solidFill>
-              <a:srgbClr val="F7FAF9"/>
-            </a:solidFill>
-            <a:prstDash val="solid"/>
-          </a:ln>
-        </p:spPr>
-      </p:sp>
-      <p:sp>
-        <p:nvSpPr>
-          <p:cNvPr id="71" name="Text 69"/>
-          <p:cNvSpPr txBox="1"/>
-          <p:nvPr/>
-        </p:nvSpPr>
-        <p:spPr>
-          <a:xfrm>
-            <a:off x="10332720" y="2112264"/>
-            <a:ext cx="1152144" cy="201168"/>
-          </a:xfrm>
-          <a:prstGeom prst="rect">
-            <a:avLst/>
-          </a:prstGeom>
-          <a:noFill/>
-          <a:ln/>
-        </p:spPr>
-        <p:txBody>
-          <a:bodyPr wrap="square" lIns="0" tIns="0" rIns="0" bIns="0" rtlCol="0" anchor="ctr"/>
-          <a:lstStyle/>
-          <a:p>
-            <a:pPr indent="0" marL="0">
-              <a:buNone/>
-            </a:pPr>
-            <a:r>
-              <a:rPr lang="en-US" sz="950" b="1" dirty="0">
-                <a:solidFill>
-                  <a:srgbClr val="8FC3B5"/>
-                </a:solidFill>
-                <a:latin typeface="Consolas" pitchFamily="34" charset="0"/>
-                <a:ea typeface="Consolas" pitchFamily="34" charset="-122"/>
-                <a:cs typeface="Consolas" pitchFamily="34" charset="-120"/>
-              </a:rPr>
-              <a:t>STEP 7</a:t>
-            </a:r>
-            <a:endParaRPr lang="en-US" sz="950" dirty="0"/>
-          </a:p>
-        </p:txBody>
-      </p:sp>
-      <p:sp>
-        <p:nvSpPr>
-          <p:cNvPr id="72" name="Text 70"/>
-          <p:cNvSpPr txBox="1"/>
-          <p:nvPr/>
-        </p:nvSpPr>
-        <p:spPr>
-          <a:xfrm>
-            <a:off x="10332720" y="2304288"/>
-            <a:ext cx="1152144" cy="667512"/>
-          </a:xfrm>
-          <a:prstGeom prst="rect">
-            <a:avLst/>
-          </a:prstGeom>
-          <a:noFill/>
-          <a:ln/>
-        </p:spPr>
-        <p:txBody>
-          <a:bodyPr wrap="square" lIns="0" tIns="0" rIns="0" bIns="0" rtlCol="0" anchor="t"/>
-          <a:lstStyle/>
-          <a:p>
-            <a:pPr indent="0" marL="0">
-              <a:buNone/>
-            </a:pPr>
-            <a:r>
-              <a:rPr lang="en-US" sz="1400" b="1" dirty="0">
-                <a:solidFill>
-                  <a:srgbClr val="FFFFFF"/>
-                </a:solidFill>
-                <a:latin typeface="Cambria" pitchFamily="34" charset="0"/>
-                <a:ea typeface="Cambria" pitchFamily="34" charset="-122"/>
-                <a:cs typeface="Cambria" pitchFamily="34" charset="-120"/>
-              </a:rPr>
-              <a:t>Code</a:t>
-            </a:r>
-            <a:endParaRPr lang="en-US" sz="1400" dirty="0"/>
-          </a:p>
-        </p:txBody>
-      </p:sp>
-      <p:sp>
-        <p:nvSpPr>
-          <p:cNvPr id="73" name="Text 71"/>
-          <p:cNvSpPr txBox="1"/>
-          <p:nvPr/>
-        </p:nvSpPr>
-        <p:spPr>
-          <a:xfrm>
-            <a:off x="10314432" y="3191256"/>
-            <a:ext cx="1188720" cy="1892808"/>
-          </a:xfrm>
-          <a:prstGeom prst="rect">
-            <a:avLst/>
-          </a:prstGeom>
-          <a:noFill/>
-          <a:ln/>
-        </p:spPr>
-        <p:txBody>
-          <a:bodyPr wrap="square" lIns="0" tIns="0" rIns="0" bIns="0" rtlCol="0" anchor="t"/>
-          <a:lstStyle/>
-          <a:p>
-            <a:pPr indent="0" marL="0">
-              <a:spcAft>
-                <a:spcPts val="400"/>
-              </a:spcAft>
-              <a:buNone/>
-            </a:pPr>
-            <a:endParaRPr lang="en-US" sz="900" dirty="0"/>
-          </a:p>
-        </p:txBody>
-      </p:sp>
-      <p:sp>
-        <p:nvSpPr>
-          <p:cNvPr id="74" name="Text 72"/>
-          <p:cNvSpPr txBox="1"/>
-          <p:nvPr/>
-        </p:nvSpPr>
-        <p:spPr>
-          <a:xfrm>
-            <a:off x="10296144" y="3200400"/>
-            <a:ext cx="1225296" cy="1463040"/>
-          </a:xfrm>
-          <a:prstGeom prst="rect">
-            <a:avLst/>
-          </a:prstGeom>
-          <a:noFill/>
-          <a:ln/>
-        </p:spPr>
-        <p:txBody>
-          <a:bodyPr wrap="square" lIns="0" tIns="0" rIns="0" bIns="0" rtlCol="0" anchor="t"/>
-          <a:lstStyle/>
-          <a:p>
-            <a:pPr indent="0" marL="0">
-              <a:spcAft>
-                <a:spcPts val="600"/>
-              </a:spcAft>
-              <a:buNone/>
-            </a:pPr>
-            <a:r>
-              <a:rPr lang="en-US" sz="950" dirty="0">
-                <a:solidFill>
-                  <a:srgbClr val="16202B"/>
-                </a:solidFill>
-                <a:latin typeface="Calibri" pitchFamily="34" charset="0"/>
-                <a:ea typeface="Calibri" pitchFamily="34" charset="-122"/>
-                <a:cs typeface="Calibri" pitchFamily="34" charset="-120"/>
-              </a:rPr>
-              <a:t>Runnable code in the investigator's software, never executed by Mallard.</a:t>
-            </a:r>
-            <a:endParaRPr lang="en-US" sz="950" dirty="0"/>
-          </a:p>
-          <a:p>
-            <a:pPr indent="0" marL="0">
-              <a:buNone/>
-            </a:pPr>
-            <a:r>
-              <a:rPr lang="en-US" sz="950" b="1" dirty="0">
-                <a:solidFill>
-                  <a:srgbClr val="0F4C43"/>
-                </a:solidFill>
-                <a:latin typeface="Calibri" pitchFamily="34" charset="0"/>
-                <a:ea typeface="Calibri" pitchFamily="34" charset="-122"/>
-                <a:cs typeface="Calibri" pitchFamily="34" charset="-120"/>
-              </a:rPr>
-              <a:t>On request.</a:t>
-            </a:r>
-            <a:endParaRPr lang="en-US" sz="950" dirty="0"/>
-          </a:p>
-        </p:txBody>
-      </p:sp>
-      <p:sp>
-        <p:nvSpPr>
-          <p:cNvPr id="75" name="Shape 73"/>
-          <p:cNvSpPr/>
-          <p:nvPr/>
-        </p:nvSpPr>
-        <p:spPr>
-          <a:xfrm>
-            <a:off x="10296144" y="4937760"/>
-            <a:ext cx="118872" cy="118872"/>
-          </a:xfrm>
-          <a:prstGeom prst="rect">
-            <a:avLst/>
-          </a:prstGeom>
-          <a:solidFill>
-            <a:srgbClr val="0F4C43"/>
-          </a:solidFill>
-          <a:ln w="12700">
-            <a:solidFill>
-              <a:srgbClr val="0F4C43"/>
-            </a:solidFill>
-            <a:prstDash val="solid"/>
-          </a:ln>
-        </p:spPr>
-      </p:sp>
-      <p:sp>
-        <p:nvSpPr>
-          <p:cNvPr id="76" name="Shape 74"/>
+          <p:cNvPr id="64" name="Shape 62"/>
           <p:cNvSpPr/>
           <p:nvPr/>
         </p:nvSpPr>
@@ -6299,7 +5885,7 @@
       </p:sp>
       <p:sp>
         <p:nvSpPr>
-          <p:cNvPr id="77" name="Text 75"/>
+          <p:cNvPr id="65" name="Text 63"/>
           <p:cNvSpPr txBox="1"/>
           <p:nvPr/>
         </p:nvSpPr>
@@ -6330,7 +5916,7 @@
                 <a:ea typeface="Calibri" pitchFamily="34" charset="-122"/>
                 <a:cs typeface="Calibri" pitchFamily="34" charset="-120"/>
               </a:rPr>
-              <a:t>Each step drafts only its own sections. The investigator's answers are pinned as facts no later step can overwrite, and re-running a step marks everything after it stale.</a:t>
+              <a:t>A later decision can reopen an earlier phase. Before an edit is saved, the investigator sees what generated work it affects and what is preserved.</a:t>
             </a:r>
             <a:endParaRPr lang="en-US" sz="1450" dirty="0"/>
           </a:p>
@@ -7232,7 +6818,7 @@
                 <a:ea typeface="Calibri" pitchFamily="34" charset="-122"/>
                 <a:cs typeface="Calibri" pitchFamily="34" charset="-120"/>
               </a:rPr>
-              <a:t>Two reviews, one guarded revision, a judge that never edits, and then the code</a:t>
+              <a:t>Two reviews, one guarded revision, a judge that never edits, then the code, then the investigator</a:t>
             </a:r>
             <a:endParaRPr lang="en-US" sz="1500" dirty="0"/>
           </a:p>
@@ -7966,7 +7552,7 @@
                 <a:ea typeface="Calibri" pitchFamily="34" charset="-122"/>
                 <a:cs typeface="Calibri" pitchFamily="34" charset="-120"/>
               </a:rPr>
-              <a:t>Open findings become one form: values only they know, contradictions to reconcile, mechanical fixes. One button, one revision, one credit.</a:t>
+              <a:t>An edit to a confirmed decision is previewed with the work it affects. Update affected sections regenerates only the stale parts, and the result is held with a diff until it is accepted or discarded.</a:t>
             </a:r>
             <a:endParaRPr lang="en-US" sz="1100" dirty="0"/>
           </a:p>
@@ -9084,7 +8670,7 @@
                 <a:ea typeface="Calibri" pitchFamily="34" charset="-122"/>
                 <a:cs typeface="Calibri" pitchFamily="34" charset="-120"/>
               </a:rPr>
-              <a:t>●  11 typed inputs</a:t>
+              <a:t>●  11 typed inputs and 4 presses</a:t>
             </a:r>
             <a:endParaRPr lang="en-US" sz="1200" dirty="0"/>
           </a:p>
@@ -9104,7 +8690,7 @@
                 <a:ea typeface="Calibri" pitchFamily="34" charset="-122"/>
                 <a:cs typeface="Calibri" pitchFamily="34" charset="-120"/>
               </a:rPr>
-              <a:t>Context fields, aims and hypotheses, feasibility answers, estimand and variables, analysis contract and sizing inputs, counts, execution, finalisation.</a:t>
+              <a:t>Context fields, aims and hypotheses, feasibility answers, estimand and variables, answers to the model, analysis contract and sizing inputs, counts, execution, finalisation. Presses: build study, draft analyses, draft execution, write-up and code.</a:t>
             </a:r>
             <a:endParaRPr lang="en-US" sz="1200" dirty="0"/>
           </a:p>
@@ -9144,7 +8730,7 @@
                 <a:ea typeface="Calibri" pitchFamily="34" charset="-122"/>
                 <a:cs typeface="Calibri" pitchFamily="34" charset="-120"/>
               </a:rPr>
-              <a:t>Confirmatory or not, aims-check disposition, basis per answer, approve or alternative, each design condition, biostatistician review, multiplicity, data requests, revise, readiness, write-up and code.</a:t>
+              <a:t>Confirmatory or not, aims-check disposition, basis per answer, approve or alternative, each design condition, data requests, multiplicity, save or update after an edit, accept or discard a result, readiness, write-up and code.</a:t>
             </a:r>
             <a:endParaRPr lang="en-US" sz="1200" dirty="0"/>
           </a:p>
@@ -9652,7 +9238,7 @@
                 <a:ea typeface="Calibri" pitchFamily="34" charset="-122"/>
                 <a:cs typeface="Calibri" pitchFamily="34" charset="-120"/>
               </a:rPr>
-              <a:t>●  11 gates and checks</a:t>
+              <a:t>●  Six phase gates and the checks between them</a:t>
             </a:r>
             <a:endParaRPr lang="en-US" sz="1200" dirty="0"/>
           </a:p>
@@ -9672,7 +9258,7 @@
                 <a:ea typeface="Calibri" pitchFamily="34" charset="-122"/>
                 <a:cs typeface="Calibri" pitchFamily="34" charset="-120"/>
               </a:rPr>
-              <a:t>PHI stripping, context, question, feasibility, conflict, design, credit, 37 plan checks, counts, analysis, execution and finalisation gates, then the export.</a:t>
+              <a:t>PHI stripping, the conflict gate, the credit check, the 37 plan checks, the recomputed number, count reconciliation, the stale-dependency map and the pending-result guard, then the export.</a:t>
             </a:r>
             <a:endParaRPr lang="en-US" sz="1200" dirty="0"/>
           </a:p>
@@ -9776,7 +9362,7 @@
                 <a:ea typeface="Calibri" pitchFamily="34" charset="-122"/>
                 <a:cs typeface="Calibri" pitchFamily="34" charset="-120"/>
               </a:rPr>
-              <a:t>The one loop back from the code lane to the models is the investigator's fixup form, and it costs a credit.</a:t>
+              <a:t>The one loop back from the code lane to the models is an investigator's decision edit, and its result waits for acceptance.</a:t>
             </a:r>
             <a:endParaRPr lang="en-US" sz="1450" dirty="0"/>
           </a:p>
@@ -9847,7 +9433,7 @@
                 <a:ea typeface="Cambria" pitchFamily="34" charset="-122"/>
                 <a:cs typeface="Cambria" pitchFamily="34" charset="-120"/>
               </a:rPr>
-              <a:t>One panel of the process map: analysis and sizing</a:t>
+              <a:t>One panel of the process map: revision inside Phase 4</a:t>
             </a:r>
             <a:endParaRPr lang="en-US" sz="3400" dirty="0"/>
           </a:p>
@@ -9886,7 +9472,7 @@
                 <a:ea typeface="Calibri" pitchFamily="34" charset="-122"/>
                 <a:cs typeface="Calibri" pitchFamily="34" charset="-120"/>
               </a:rPr>
-              <a:t>Parallelogram = investigator input · diamond = decision · rectangle = process · numbered circle = continues on the next panel</a:t>
+              <a:t>Parallelogram = investigator input · diamond = decision · rectangle = process · numbered circle = continues on another panel</a:t>
             </a:r>
             <a:endParaRPr lang="en-US" sz="1500" dirty="0"/>
           </a:p>
@@ -9894,7 +9480,7 @@
       </p:sp>
       <p:pic>
         <p:nvPicPr>
-          <p:cNvPr id="4" name="Image 0" descr="panelD.png">    </p:cNvPr>
+          <p:cNvPr id="4" name="Image 0" descr="panelE.png">    </p:cNvPr>
           <p:cNvPicPr>
             <a:picLocks noChangeAspect="1"/>
           </p:cNvPicPr>
@@ -9972,7 +9558,7 @@
                 <a:ea typeface="Calibri" pitchFamily="34" charset="-122"/>
                 <a:cs typeface="Calibri" pitchFamily="34" charset="-120"/>
               </a:rPr>
-              <a:t>The investigator supplies the contract and presses Calculate; the code recomputes the number and runs the checks; the fixup form is the only route back to the models.</a:t>
+              <a:t>Multiplicity and counts are investigator decisions. An edit is previewed, affected work is marked stale, an update regenerates only that work, and the result waits for acceptance.</a:t>
             </a:r>
             <a:endParaRPr lang="en-US" sz="1050" dirty="0"/>
           </a:p>
@@ -10001,7 +9587,7 @@
                 <a:ea typeface="Calibri" pitchFamily="34" charset="-122"/>
                 <a:cs typeface="Calibri" pitchFamily="34" charset="-120"/>
               </a:rPr>
-              <a:t>Five panels cover the whole flow, tagged I1 to I11 and D1 to D11.</a:t>
+              <a:t>Six panels cover the whole flow, tagged I1 to I11 and D1 to D11.</a:t>
             </a:r>
             <a:endParaRPr lang="en-US" sz="1050" dirty="0"/>
           </a:p>
@@ -10537,7 +10123,7 @@
                 <a:ea typeface="Calibri" pitchFamily="34" charset="-122"/>
                 <a:cs typeface="Calibri" pitchFamily="34" charset="-120"/>
               </a:rPr>
-              <a:t>Code feasibility gate; a task blocks design until closed</a:t>
+              <a:t>Code Phase 2 gate; a task blocks design until closed</a:t>
             </a:r>
             <a:endParaRPr lang="en-US" sz="1050" dirty="0"/>
           </a:p>
@@ -10821,7 +10407,7 @@
                 <a:ea typeface="Calibri" pitchFamily="34" charset="-122"/>
                 <a:cs typeface="Calibri" pitchFamily="34" charset="-120"/>
               </a:rPr>
-              <a:t>Investigator defines the estimand and variables</a:t>
+              <a:t>Code Phase 3 gate, then the design confirmation</a:t>
             </a:r>
             <a:endParaRPr lang="en-US" sz="1050" dirty="0"/>
           </a:p>
@@ -10924,7 +10510,7 @@
                 <a:ea typeface="Calibri" pitchFamily="34" charset="-122"/>
                 <a:cs typeface="Calibri" pitchFamily="34" charset="-120"/>
               </a:rPr>
-              <a:t>Request a biostatistician design review?</a:t>
+              <a:t>Data beyond the map: add it, or remove from the analysis</a:t>
             </a:r>
             <a:endParaRPr lang="en-US" sz="1250" dirty="0"/>
           </a:p>
@@ -10963,7 +10549,7 @@
                 <a:ea typeface="Calibri" pitchFamily="34" charset="-122"/>
                 <a:cs typeface="Calibri" pitchFamily="34" charset="-120"/>
               </a:rPr>
-              <a:t>Code pins the review to the decisions; any change makes it stale</a:t>
+              <a:t>Investigator fills the analysis contract</a:t>
             </a:r>
             <a:endParaRPr lang="en-US" sz="1050" dirty="0"/>
           </a:p>
@@ -11105,7 +10691,7 @@
                 <a:ea typeface="Calibri" pitchFamily="34" charset="-122"/>
                 <a:cs typeface="Calibri" pitchFamily="34" charset="-120"/>
               </a:rPr>
-              <a:t>Code analysis gate</a:t>
+              <a:t>Investigator reconciles counts; code Phase 4 gate</a:t>
             </a:r>
             <a:endParaRPr lang="en-US" sz="1050" dirty="0"/>
           </a:p>
@@ -11208,7 +10794,7 @@
                 <a:ea typeface="Calibri" pitchFamily="34" charset="-122"/>
                 <a:cs typeface="Calibri" pitchFamily="34" charset="-120"/>
               </a:rPr>
-              <a:t>Data beyond the map: add it, or remove from the analysis</a:t>
+              <a:t>After an edit: save only, or update the affected sections</a:t>
             </a:r>
             <a:endParaRPr lang="en-US" sz="1250" dirty="0"/>
           </a:p>
@@ -11247,7 +10833,7 @@
                 <a:ea typeface="Calibri" pitchFamily="34" charset="-122"/>
                 <a:cs typeface="Calibri" pitchFamily="34" charset="-120"/>
               </a:rPr>
-              <a:t>Code analysis gate</a:t>
+              <a:t>Code marks stale work; models regenerate only that</a:t>
             </a:r>
             <a:endParaRPr lang="en-US" sz="1050" dirty="0"/>
           </a:p>
@@ -11350,7 +10936,7 @@
                 <a:ea typeface="Calibri" pitchFamily="34" charset="-122"/>
                 <a:cs typeface="Calibri" pitchFamily="34" charset="-120"/>
               </a:rPr>
-              <a:t>Send the fixup form as one revision?</a:t>
+              <a:t>Accept or discard the generated changes</a:t>
             </a:r>
             <a:endParaRPr lang="en-US" sz="1250" dirty="0"/>
           </a:p>
@@ -11389,7 +10975,7 @@
                 <a:ea typeface="Calibri" pitchFamily="34" charset="-122"/>
                 <a:cs typeface="Calibri" pitchFamily="34" charset="-120"/>
               </a:rPr>
-              <a:t>Models: guarded patch and adjudication; one credit</a:t>
+              <a:t>Code Phase 4 gate; the result is refused if decisions moved</a:t>
             </a:r>
             <a:endParaRPr lang="en-US" sz="1050" dirty="0"/>
           </a:p>
@@ -11531,7 +11117,7 @@
                 <a:ea typeface="Calibri" pitchFamily="34" charset="-122"/>
                 <a:cs typeface="Calibri" pitchFamily="34" charset="-120"/>
               </a:rPr>
-              <a:t>Code execution gate; infeasible blocks the phase</a:t>
+              <a:t>Code Phase 5 gate; infeasible blocks the phase</a:t>
             </a:r>
             <a:endParaRPr lang="en-US" sz="1050" dirty="0"/>
           </a:p>
@@ -11634,7 +11220,7 @@
                 <a:ea typeface="Calibri" pitchFamily="34" charset="-122"/>
                 <a:cs typeface="Calibri" pitchFamily="34" charset="-120"/>
               </a:rPr>
-              <a:t>Request the write-up and code, and in which languages</a:t>
+              <a:t>Request the written package and code, and in which languages</a:t>
             </a:r>
             <a:endParaRPr lang="en-US" sz="1250" dirty="0"/>
           </a:p>
@@ -11673,7 +11259,7 @@
                 <a:ea typeface="Calibri" pitchFamily="34" charset="-122"/>
                 <a:cs typeface="Calibri" pitchFamily="34" charset="-120"/>
               </a:rPr>
-              <a:t>Models draft steps 6 and 7 on request; code is never executed</a:t>
+              <a:t>Models draft them on request; code is never executed</a:t>
             </a:r>
             <a:endParaRPr lang="en-US" sz="1050" dirty="0"/>
           </a:p>
@@ -11737,7 +11323,7 @@
                 <a:ea typeface="Calibri" pitchFamily="34" charset="-122"/>
                 <a:cs typeface="Calibri" pitchFamily="34" charset="-120"/>
               </a:rPr>
-              <a:t>Eleven more items are typed inputs rather than choices: the context fields, aims, hypotheses, feasibility answers, conflict answers, estimand and variables, the model's questions, the analysis contract, counts, execution fields and finalisation.</a:t>
+              <a:t>Eleven more items are typed inputs rather than choices, and four are presses: build the study, draft the analyses, draft execution, and request the written package and code.</a:t>
             </a:r>
             <a:endParaRPr lang="en-US" sz="1000" dirty="0"/>
           </a:p>

</xml_diff>